<commit_message>
Poster: NASA/JPL logo beside the MAIA mark in the header
The NASA/JPL logo comes from the 2025 AAAR poster (trimmed to 892 x 168 px, now in
figures/logos/nasa_jpl.png) and sits vertically centred next to MAIA, with the SPARTAN
logo below. The poster is rebuilt and the draft PDF re-rendered; the layout is otherwise
unchanged.

Co-Authored-By: Claude Opus 5.5 <noreply@anthropic.com>
</commit_message>
<xml_diff>
--- a/deliverables/aaar_poster_2026/aaar_poster_2026.pptx
+++ b/deliverables/aaar_poster_2026/aaar_poster_2026.pptx
@@ -3343,7 +3343,7 @@
       </p:pic>
       <p:pic>
         <p:nvPicPr>
-          <p:cNvPr id="9" name="Picture 8" descr="maia.png"/>
+          <p:cNvPr id="9" name="Picture 8" descr="nasa_jpl.png"/>
           <p:cNvPicPr>
             <a:picLocks noChangeAspect="1"/>
           </p:cNvPicPr>
@@ -3357,8 +3357,8 @@
         </p:blipFill>
         <p:spPr>
           <a:xfrm>
-            <a:off x="33329880" y="731520"/>
-            <a:ext cx="2651760" cy="2651760"/>
+            <a:off x="30175200" y="1490472"/>
+            <a:ext cx="6035040" cy="1136644"/>
           </a:xfrm>
           <a:prstGeom prst="rect">
             <a:avLst/>
@@ -3367,7 +3367,7 @@
       </p:pic>
       <p:pic>
         <p:nvPicPr>
-          <p:cNvPr id="10" name="Picture 9" descr="spartan_cyan.png"/>
+          <p:cNvPr id="10" name="Picture 9" descr="maia.png"/>
           <p:cNvPicPr>
             <a:picLocks noChangeAspect="1"/>
           </p:cNvPicPr>
@@ -3381,392 +3381,17 @@
         </p:blipFill>
         <p:spPr>
           <a:xfrm>
-            <a:off x="31272480" y="3611880"/>
-            <a:ext cx="6766560" cy="1583119"/>
+            <a:off x="36530280" y="731520"/>
+            <a:ext cx="2651760" cy="2651760"/>
           </a:xfrm>
           <a:prstGeom prst="rect">
             <a:avLst/>
           </a:prstGeom>
         </p:spPr>
       </p:pic>
-      <p:sp>
-        <p:nvSpPr>
-          <p:cNvPr id="11" name="Rectangle 10"/>
-          <p:cNvSpPr/>
-          <p:nvPr/>
-        </p:nvSpPr>
-        <p:spPr>
-          <a:xfrm>
-            <a:off x="777240" y="6446520"/>
-            <a:ext cx="12527280" cy="34061400"/>
-          </a:xfrm>
-          <a:prstGeom prst="rect">
-            <a:avLst/>
-          </a:prstGeom>
-          <a:solidFill>
-            <a:srgbClr val="FFFFFF"/>
-          </a:solidFill>
-          <a:ln>
-            <a:noFill/>
-          </a:ln>
-          <a:effectLst/>
-        </p:spPr>
-        <p:style>
-          <a:lnRef idx="1">
-            <a:schemeClr val="accent1"/>
-          </a:lnRef>
-          <a:fillRef idx="3">
-            <a:schemeClr val="accent1"/>
-          </a:fillRef>
-          <a:effectRef idx="2">
-            <a:schemeClr val="accent1"/>
-          </a:effectRef>
-          <a:fontRef idx="minor">
-            <a:schemeClr val="lt1"/>
-          </a:fontRef>
-        </p:style>
-        <p:txBody>
-          <a:bodyPr rtlCol="0" anchor="ctr"/>
-          <a:lstStyle/>
-          <a:p>
-            <a:pPr algn="ctr"/>
-          </a:p>
-        </p:txBody>
-      </p:sp>
-      <p:sp>
-        <p:nvSpPr>
-          <p:cNvPr id="12" name="Rectangle 11"/>
-          <p:cNvSpPr/>
-          <p:nvPr/>
-        </p:nvSpPr>
-        <p:spPr>
-          <a:xfrm>
-            <a:off x="13853159" y="6446520"/>
-            <a:ext cx="12527280" cy="34061400"/>
-          </a:xfrm>
-          <a:prstGeom prst="rect">
-            <a:avLst/>
-          </a:prstGeom>
-          <a:solidFill>
-            <a:srgbClr val="FFFFFF"/>
-          </a:solidFill>
-          <a:ln>
-            <a:noFill/>
-          </a:ln>
-          <a:effectLst/>
-        </p:spPr>
-        <p:style>
-          <a:lnRef idx="1">
-            <a:schemeClr val="accent1"/>
-          </a:lnRef>
-          <a:fillRef idx="3">
-            <a:schemeClr val="accent1"/>
-          </a:fillRef>
-          <a:effectRef idx="2">
-            <a:schemeClr val="accent1"/>
-          </a:effectRef>
-          <a:fontRef idx="minor">
-            <a:schemeClr val="lt1"/>
-          </a:fontRef>
-        </p:style>
-        <p:txBody>
-          <a:bodyPr rtlCol="0" anchor="ctr"/>
-          <a:lstStyle/>
-          <a:p>
-            <a:pPr algn="ctr"/>
-          </a:p>
-        </p:txBody>
-      </p:sp>
-      <p:sp>
-        <p:nvSpPr>
-          <p:cNvPr id="13" name="Rectangle 12"/>
-          <p:cNvSpPr/>
-          <p:nvPr/>
-        </p:nvSpPr>
-        <p:spPr>
-          <a:xfrm>
-            <a:off x="26929080" y="6446520"/>
-            <a:ext cx="12527280" cy="34061400"/>
-          </a:xfrm>
-          <a:prstGeom prst="rect">
-            <a:avLst/>
-          </a:prstGeom>
-          <a:solidFill>
-            <a:srgbClr val="FFFFFF"/>
-          </a:solidFill>
-          <a:ln>
-            <a:noFill/>
-          </a:ln>
-          <a:effectLst/>
-        </p:spPr>
-        <p:style>
-          <a:lnRef idx="1">
-            <a:schemeClr val="accent1"/>
-          </a:lnRef>
-          <a:fillRef idx="3">
-            <a:schemeClr val="accent1"/>
-          </a:fillRef>
-          <a:effectRef idx="2">
-            <a:schemeClr val="accent1"/>
-          </a:effectRef>
-          <a:fontRef idx="minor">
-            <a:schemeClr val="lt1"/>
-          </a:fontRef>
-        </p:style>
-        <p:txBody>
-          <a:bodyPr rtlCol="0" anchor="ctr"/>
-          <a:lstStyle/>
-          <a:p>
-            <a:pPr algn="ctr"/>
-          </a:p>
-        </p:txBody>
-      </p:sp>
-      <p:sp>
-        <p:nvSpPr>
-          <p:cNvPr id="14" name="Rectangle 13"/>
-          <p:cNvSpPr/>
-          <p:nvPr/>
-        </p:nvSpPr>
-        <p:spPr>
-          <a:xfrm>
-            <a:off x="777240" y="6446520"/>
-            <a:ext cx="12527280" cy="777240"/>
-          </a:xfrm>
-          <a:prstGeom prst="rect">
-            <a:avLst/>
-          </a:prstGeom>
-          <a:solidFill>
-            <a:srgbClr val="1B365D"/>
-          </a:solidFill>
-          <a:ln>
-            <a:noFill/>
-          </a:ln>
-          <a:effectLst/>
-        </p:spPr>
-        <p:style>
-          <a:lnRef idx="1">
-            <a:schemeClr val="accent1"/>
-          </a:lnRef>
-          <a:fillRef idx="3">
-            <a:schemeClr val="accent1"/>
-          </a:fillRef>
-          <a:effectRef idx="2">
-            <a:schemeClr val="accent1"/>
-          </a:effectRef>
-          <a:fontRef idx="minor">
-            <a:schemeClr val="lt1"/>
-          </a:fontRef>
-        </p:style>
-        <p:txBody>
-          <a:bodyPr rtlCol="0" anchor="ctr" lIns="182880"/>
-          <a:lstStyle/>
-          <a:p>
-            <a:pPr algn="ctr"/>
-            <a:r>
-              <a:rPr sz="3800" b="1" i="0">
-                <a:solidFill>
-                  <a:srgbClr val="FFFFFF"/>
-                </a:solidFill>
-                <a:latin typeface="Calibri"/>
-              </a:rPr>
-              <a:t>Why elemental carbon in Addis Ababa?</a:t>
-            </a:r>
-          </a:p>
-        </p:txBody>
-      </p:sp>
-      <p:sp>
-        <p:nvSpPr>
-          <p:cNvPr id="15" name="TextBox 14"/>
-          <p:cNvSpPr txBox="1"/>
-          <p:nvPr/>
-        </p:nvSpPr>
-        <p:spPr>
-          <a:xfrm>
-            <a:off x="1051560" y="7406640"/>
-            <a:ext cx="11978640" cy="5755640"/>
-          </a:xfrm>
-          <a:prstGeom prst="rect">
-            <a:avLst/>
-          </a:prstGeom>
-          <a:noFill/>
-        </p:spPr>
-        <p:txBody>
-          <a:bodyPr wrap="square" tIns="27432" bIns="27432">
-            <a:spAutoFit/>
-          </a:bodyPr>
-          <a:lstStyle/>
-          <a:p>
-            <a:pPr algn="l" marL="384048" indent="-384048">
-              <a:spcAft>
-                <a:spcPts val="979"/>
-              </a:spcAft>
-              <a:buChar char="•"/>
-            </a:pPr>
-            <a:r>
-              <a:rPr sz="2800" b="1" i="0">
-                <a:solidFill>
-                  <a:srgbClr val="22252A"/>
-                </a:solidFill>
-                <a:latin typeface="Calibri"/>
-              </a:rPr>
-              <a:t>Elemental carbon (EC)</a:t>
-            </a:r>
-            <a:r>
-              <a:rPr sz="2800" b="0" i="0">
-                <a:solidFill>
-                  <a:srgbClr val="22252A"/>
-                </a:solidFill>
-                <a:latin typeface="Calibri"/>
-              </a:rPr>
-              <a:t> is the black, soot-like carbon from burning. It warms the climate and harms health.</a:t>
-            </a:r>
-          </a:p>
-          <a:p>
-            <a:pPr algn="l" marL="384048" indent="-384048">
-              <a:spcAft>
-                <a:spcPts val="979"/>
-              </a:spcAft>
-              <a:buChar char="•"/>
-            </a:pPr>
-            <a:r>
-              <a:rPr sz="2800" b="1" i="0">
-                <a:solidFill>
-                  <a:srgbClr val="22252A"/>
-                </a:solidFill>
-                <a:latin typeface="Calibri"/>
-              </a:rPr>
-              <a:t>SPARTAN</a:t>
-            </a:r>
-            <a:r>
-              <a:rPr sz="2800" b="0" i="0">
-                <a:solidFill>
-                  <a:srgbClr val="22252A"/>
-                </a:solidFill>
-                <a:latin typeface="Calibri"/>
-              </a:rPr>
-              <a:t> (Surface PARTiculate mAtter Network, www.spartan-network.org) samples particles onto filters in cities around the world, mostly in the Global South. It measures EC by </a:t>
-            </a:r>
-            <a:r>
-              <a:rPr sz="2800" b="1" i="0">
-                <a:solidFill>
-                  <a:srgbClr val="22252A"/>
-                </a:solidFill>
-                <a:latin typeface="Calibri"/>
-              </a:rPr>
-              <a:t>FTIR</a:t>
-            </a:r>
-            <a:r>
-              <a:rPr sz="2800" b="0" i="0">
-                <a:solidFill>
-                  <a:srgbClr val="22252A"/>
-                </a:solidFill>
-                <a:latin typeface="Calibri"/>
-              </a:rPr>
-              <a:t> (below).</a:t>
-            </a:r>
-          </a:p>
-          <a:p>
-            <a:pPr algn="l" marL="384048" indent="-384048">
-              <a:spcAft>
-                <a:spcPts val="979"/>
-              </a:spcAft>
-              <a:buChar char="•"/>
-            </a:pPr>
-            <a:r>
-              <a:rPr sz="2800" b="1" i="0">
-                <a:solidFill>
-                  <a:srgbClr val="22252A"/>
-                </a:solidFill>
-                <a:latin typeface="Calibri"/>
-              </a:rPr>
-              <a:t>Addis Ababa</a:t>
-            </a:r>
-            <a:r>
-              <a:rPr sz="2800" b="0" i="0">
-                <a:solidFill>
-                  <a:srgbClr val="22252A"/>
-                </a:solidFill>
-                <a:latin typeface="Calibri"/>
-              </a:rPr>
-              <a:t>, capital of Ethiopia (about 2,400 m elevation, about 5 million people), has some of the highest EC in SPARTAN. Households cook and heat with wood and charcoal.</a:t>
-            </a:r>
-          </a:p>
-          <a:p>
-            <a:pPr algn="l" marL="384048" indent="-384048">
-              <a:spcAft>
-                <a:spcPts val="979"/>
-              </a:spcAft>
-              <a:buChar char="•"/>
-            </a:pPr>
-            <a:r>
-              <a:rPr sz="2800" b="0" i="0">
-                <a:solidFill>
-                  <a:srgbClr val="22252A"/>
-                </a:solidFill>
-                <a:latin typeface="Calibri"/>
-              </a:rPr>
-              <a:t>We use 189 Addis filters (Dec 2022 to Sep 2024) across three seasons: </a:t>
-            </a:r>
-            <a:r>
-              <a:rPr sz="2800" b="1" i="0">
-                <a:solidFill>
-                  <a:srgbClr val="22252A"/>
-                </a:solidFill>
-                <a:latin typeface="Calibri"/>
-              </a:rPr>
-              <a:t>Dry</a:t>
-            </a:r>
-            <a:r>
-              <a:rPr sz="2800" b="0" i="0">
-                <a:solidFill>
-                  <a:srgbClr val="22252A"/>
-                </a:solidFill>
-                <a:latin typeface="Calibri"/>
-              </a:rPr>
-              <a:t> (Bega, Oct to Feb), </a:t>
-            </a:r>
-            <a:r>
-              <a:rPr sz="2800" b="1" i="0">
-                <a:solidFill>
-                  <a:srgbClr val="22252A"/>
-                </a:solidFill>
-                <a:latin typeface="Calibri"/>
-              </a:rPr>
-              <a:t>Belg</a:t>
-            </a:r>
-            <a:r>
-              <a:rPr sz="2800" b="0" i="0">
-                <a:solidFill>
-                  <a:srgbClr val="22252A"/>
-                </a:solidFill>
-                <a:latin typeface="Calibri"/>
-              </a:rPr>
-              <a:t> short rains (Mar to May) and </a:t>
-            </a:r>
-            <a:r>
-              <a:rPr sz="2800" b="1" i="0">
-                <a:solidFill>
-                  <a:srgbClr val="22252A"/>
-                </a:solidFill>
-                <a:latin typeface="Calibri"/>
-              </a:rPr>
-              <a:t>Kiremt</a:t>
-            </a:r>
-            <a:r>
-              <a:rPr sz="2800" b="0" i="0">
-                <a:solidFill>
-                  <a:srgbClr val="22252A"/>
-                </a:solidFill>
-                <a:latin typeface="Calibri"/>
-              </a:rPr>
-              <a:t> long rains (Jun to Sep). All 246 Addis filters in the public SPARTAN release give the same result.</a:t>
-            </a:r>
-          </a:p>
-        </p:txBody>
-      </p:sp>
       <p:pic>
         <p:nvPicPr>
-          <p:cNvPr id="16" name="Picture 15" descr="f0_network_map.png"/>
+          <p:cNvPr id="11" name="Picture 10" descr="spartan_cyan.png"/>
           <p:cNvPicPr>
             <a:picLocks noChangeAspect="1"/>
           </p:cNvPicPr>
@@ -3780,8 +3405,8 @@
         </p:blipFill>
         <p:spPr>
           <a:xfrm>
-            <a:off x="2240280" y="13162280"/>
-            <a:ext cx="9601200" cy="4467084"/>
+            <a:off x="31272480" y="3611880"/>
+            <a:ext cx="6766560" cy="1583119"/>
           </a:xfrm>
           <a:prstGeom prst="rect">
             <a:avLst/>
@@ -3790,61 +3415,145 @@
       </p:pic>
       <p:sp>
         <p:nvSpPr>
-          <p:cNvPr id="17" name="TextBox 16"/>
-          <p:cNvSpPr txBox="1"/>
+          <p:cNvPr id="12" name="Rectangle 11"/>
+          <p:cNvSpPr/>
           <p:nvPr/>
         </p:nvSpPr>
         <p:spPr>
           <a:xfrm>
-            <a:off x="1051560" y="17675084"/>
-            <a:ext cx="11978640" cy="896620"/>
+            <a:off x="777240" y="6446520"/>
+            <a:ext cx="12527280" cy="34061400"/>
           </a:xfrm>
           <a:prstGeom prst="rect">
             <a:avLst/>
           </a:prstGeom>
-          <a:noFill/>
-        </p:spPr>
-        <p:txBody>
-          <a:bodyPr wrap="square" tIns="27432" bIns="27432">
-            <a:spAutoFit/>
-          </a:bodyPr>
-          <a:lstStyle/>
-          <a:p>
-            <a:pPr algn="l">
-              <a:spcAft>
-                <a:spcPts val="460"/>
-              </a:spcAft>
-            </a:pPr>
-            <a:r>
-              <a:rPr sz="2300" b="1" i="0">
-                <a:solidFill>
-                  <a:srgbClr val="55585E"/>
-                </a:solidFill>
-                <a:latin typeface="Calibri"/>
-              </a:rPr>
-              <a:t>Figure 1.</a:t>
-            </a:r>
-            <a:r>
-              <a:rPr sz="2300" b="0" i="0">
-                <a:solidFill>
-                  <a:srgbClr val="55585E"/>
-                </a:solidFill>
-                <a:latin typeface="Calibri"/>
-              </a:rPr>
-              <a:t> Where the filters come from. Grey: IMPROVE sites (US), which provide the calibration. Blue stars: SPARTAN sites, where the calibration is applied.</a:t>
-            </a:r>
-          </a:p>
-        </p:txBody>
-      </p:sp>
-      <p:sp>
-        <p:nvSpPr>
-          <p:cNvPr id="18" name="Rectangle 17"/>
+          <a:solidFill>
+            <a:srgbClr val="FFFFFF"/>
+          </a:solidFill>
+          <a:ln>
+            <a:noFill/>
+          </a:ln>
+          <a:effectLst/>
+        </p:spPr>
+        <p:style>
+          <a:lnRef idx="1">
+            <a:schemeClr val="accent1"/>
+          </a:lnRef>
+          <a:fillRef idx="3">
+            <a:schemeClr val="accent1"/>
+          </a:fillRef>
+          <a:effectRef idx="2">
+            <a:schemeClr val="accent1"/>
+          </a:effectRef>
+          <a:fontRef idx="minor">
+            <a:schemeClr val="lt1"/>
+          </a:fontRef>
+        </p:style>
+        <p:txBody>
+          <a:bodyPr rtlCol="0" anchor="ctr"/>
+          <a:lstStyle/>
+          <a:p>
+            <a:pPr algn="ctr"/>
+          </a:p>
+        </p:txBody>
+      </p:sp>
+      <p:sp>
+        <p:nvSpPr>
+          <p:cNvPr id="13" name="Rectangle 12"/>
           <p:cNvSpPr/>
           <p:nvPr/>
         </p:nvSpPr>
         <p:spPr>
           <a:xfrm>
-            <a:off x="777240" y="18800304"/>
+            <a:off x="13853159" y="6446520"/>
+            <a:ext cx="12527280" cy="34061400"/>
+          </a:xfrm>
+          <a:prstGeom prst="rect">
+            <a:avLst/>
+          </a:prstGeom>
+          <a:solidFill>
+            <a:srgbClr val="FFFFFF"/>
+          </a:solidFill>
+          <a:ln>
+            <a:noFill/>
+          </a:ln>
+          <a:effectLst/>
+        </p:spPr>
+        <p:style>
+          <a:lnRef idx="1">
+            <a:schemeClr val="accent1"/>
+          </a:lnRef>
+          <a:fillRef idx="3">
+            <a:schemeClr val="accent1"/>
+          </a:fillRef>
+          <a:effectRef idx="2">
+            <a:schemeClr val="accent1"/>
+          </a:effectRef>
+          <a:fontRef idx="minor">
+            <a:schemeClr val="lt1"/>
+          </a:fontRef>
+        </p:style>
+        <p:txBody>
+          <a:bodyPr rtlCol="0" anchor="ctr"/>
+          <a:lstStyle/>
+          <a:p>
+            <a:pPr algn="ctr"/>
+          </a:p>
+        </p:txBody>
+      </p:sp>
+      <p:sp>
+        <p:nvSpPr>
+          <p:cNvPr id="14" name="Rectangle 13"/>
+          <p:cNvSpPr/>
+          <p:nvPr/>
+        </p:nvSpPr>
+        <p:spPr>
+          <a:xfrm>
+            <a:off x="26929080" y="6446520"/>
+            <a:ext cx="12527280" cy="34061400"/>
+          </a:xfrm>
+          <a:prstGeom prst="rect">
+            <a:avLst/>
+          </a:prstGeom>
+          <a:solidFill>
+            <a:srgbClr val="FFFFFF"/>
+          </a:solidFill>
+          <a:ln>
+            <a:noFill/>
+          </a:ln>
+          <a:effectLst/>
+        </p:spPr>
+        <p:style>
+          <a:lnRef idx="1">
+            <a:schemeClr val="accent1"/>
+          </a:lnRef>
+          <a:fillRef idx="3">
+            <a:schemeClr val="accent1"/>
+          </a:fillRef>
+          <a:effectRef idx="2">
+            <a:schemeClr val="accent1"/>
+          </a:effectRef>
+          <a:fontRef idx="minor">
+            <a:schemeClr val="lt1"/>
+          </a:fontRef>
+        </p:style>
+        <p:txBody>
+          <a:bodyPr rtlCol="0" anchor="ctr"/>
+          <a:lstStyle/>
+          <a:p>
+            <a:pPr algn="ctr"/>
+          </a:p>
+        </p:txBody>
+      </p:sp>
+      <p:sp>
+        <p:nvSpPr>
+          <p:cNvPr id="15" name="Rectangle 14"/>
+          <p:cNvSpPr/>
+          <p:nvPr/>
+        </p:nvSpPr>
+        <p:spPr>
+          <a:xfrm>
+            <a:off x="777240" y="6446520"/>
             <a:ext cx="12527280" cy="777240"/>
           </a:xfrm>
           <a:prstGeom prst="rect">
@@ -3884,6 +3593,321 @@
                 </a:solidFill>
                 <a:latin typeface="Calibri"/>
               </a:rPr>
+              <a:t>Why elemental carbon in Addis Ababa?</a:t>
+            </a:r>
+          </a:p>
+        </p:txBody>
+      </p:sp>
+      <p:sp>
+        <p:nvSpPr>
+          <p:cNvPr id="16" name="TextBox 15"/>
+          <p:cNvSpPr txBox="1"/>
+          <p:nvPr/>
+        </p:nvSpPr>
+        <p:spPr>
+          <a:xfrm>
+            <a:off x="1051560" y="7406640"/>
+            <a:ext cx="11978640" cy="5755640"/>
+          </a:xfrm>
+          <a:prstGeom prst="rect">
+            <a:avLst/>
+          </a:prstGeom>
+          <a:noFill/>
+        </p:spPr>
+        <p:txBody>
+          <a:bodyPr wrap="square" tIns="27432" bIns="27432">
+            <a:spAutoFit/>
+          </a:bodyPr>
+          <a:lstStyle/>
+          <a:p>
+            <a:pPr algn="l" marL="384048" indent="-384048">
+              <a:spcAft>
+                <a:spcPts val="979"/>
+              </a:spcAft>
+              <a:buChar char="•"/>
+            </a:pPr>
+            <a:r>
+              <a:rPr sz="2800" b="1" i="0">
+                <a:solidFill>
+                  <a:srgbClr val="22252A"/>
+                </a:solidFill>
+                <a:latin typeface="Calibri"/>
+              </a:rPr>
+              <a:t>Elemental carbon (EC)</a:t>
+            </a:r>
+            <a:r>
+              <a:rPr sz="2800" b="0" i="0">
+                <a:solidFill>
+                  <a:srgbClr val="22252A"/>
+                </a:solidFill>
+                <a:latin typeface="Calibri"/>
+              </a:rPr>
+              <a:t> is the black, soot-like carbon from burning. It warms the climate and harms health.</a:t>
+            </a:r>
+          </a:p>
+          <a:p>
+            <a:pPr algn="l" marL="384048" indent="-384048">
+              <a:spcAft>
+                <a:spcPts val="979"/>
+              </a:spcAft>
+              <a:buChar char="•"/>
+            </a:pPr>
+            <a:r>
+              <a:rPr sz="2800" b="1" i="0">
+                <a:solidFill>
+                  <a:srgbClr val="22252A"/>
+                </a:solidFill>
+                <a:latin typeface="Calibri"/>
+              </a:rPr>
+              <a:t>SPARTAN</a:t>
+            </a:r>
+            <a:r>
+              <a:rPr sz="2800" b="0" i="0">
+                <a:solidFill>
+                  <a:srgbClr val="22252A"/>
+                </a:solidFill>
+                <a:latin typeface="Calibri"/>
+              </a:rPr>
+              <a:t> (Surface PARTiculate mAtter Network, www.spartan-network.org) samples particles onto filters in cities around the world, mostly in the Global South. It measures EC by </a:t>
+            </a:r>
+            <a:r>
+              <a:rPr sz="2800" b="1" i="0">
+                <a:solidFill>
+                  <a:srgbClr val="22252A"/>
+                </a:solidFill>
+                <a:latin typeface="Calibri"/>
+              </a:rPr>
+              <a:t>FTIR</a:t>
+            </a:r>
+            <a:r>
+              <a:rPr sz="2800" b="0" i="0">
+                <a:solidFill>
+                  <a:srgbClr val="22252A"/>
+                </a:solidFill>
+                <a:latin typeface="Calibri"/>
+              </a:rPr>
+              <a:t> (below).</a:t>
+            </a:r>
+          </a:p>
+          <a:p>
+            <a:pPr algn="l" marL="384048" indent="-384048">
+              <a:spcAft>
+                <a:spcPts val="979"/>
+              </a:spcAft>
+              <a:buChar char="•"/>
+            </a:pPr>
+            <a:r>
+              <a:rPr sz="2800" b="1" i="0">
+                <a:solidFill>
+                  <a:srgbClr val="22252A"/>
+                </a:solidFill>
+                <a:latin typeface="Calibri"/>
+              </a:rPr>
+              <a:t>Addis Ababa</a:t>
+            </a:r>
+            <a:r>
+              <a:rPr sz="2800" b="0" i="0">
+                <a:solidFill>
+                  <a:srgbClr val="22252A"/>
+                </a:solidFill>
+                <a:latin typeface="Calibri"/>
+              </a:rPr>
+              <a:t>, capital of Ethiopia (about 2,400 m elevation, about 5 million people), has some of the highest EC in SPARTAN. Households cook and heat with wood and charcoal.</a:t>
+            </a:r>
+          </a:p>
+          <a:p>
+            <a:pPr algn="l" marL="384048" indent="-384048">
+              <a:spcAft>
+                <a:spcPts val="979"/>
+              </a:spcAft>
+              <a:buChar char="•"/>
+            </a:pPr>
+            <a:r>
+              <a:rPr sz="2800" b="0" i="0">
+                <a:solidFill>
+                  <a:srgbClr val="22252A"/>
+                </a:solidFill>
+                <a:latin typeface="Calibri"/>
+              </a:rPr>
+              <a:t>We use 189 Addis filters (Dec 2022 to Sep 2024) across three seasons: </a:t>
+            </a:r>
+            <a:r>
+              <a:rPr sz="2800" b="1" i="0">
+                <a:solidFill>
+                  <a:srgbClr val="22252A"/>
+                </a:solidFill>
+                <a:latin typeface="Calibri"/>
+              </a:rPr>
+              <a:t>Dry</a:t>
+            </a:r>
+            <a:r>
+              <a:rPr sz="2800" b="0" i="0">
+                <a:solidFill>
+                  <a:srgbClr val="22252A"/>
+                </a:solidFill>
+                <a:latin typeface="Calibri"/>
+              </a:rPr>
+              <a:t> (Bega, Oct to Feb), </a:t>
+            </a:r>
+            <a:r>
+              <a:rPr sz="2800" b="1" i="0">
+                <a:solidFill>
+                  <a:srgbClr val="22252A"/>
+                </a:solidFill>
+                <a:latin typeface="Calibri"/>
+              </a:rPr>
+              <a:t>Belg</a:t>
+            </a:r>
+            <a:r>
+              <a:rPr sz="2800" b="0" i="0">
+                <a:solidFill>
+                  <a:srgbClr val="22252A"/>
+                </a:solidFill>
+                <a:latin typeface="Calibri"/>
+              </a:rPr>
+              <a:t> short rains (Mar to May) and </a:t>
+            </a:r>
+            <a:r>
+              <a:rPr sz="2800" b="1" i="0">
+                <a:solidFill>
+                  <a:srgbClr val="22252A"/>
+                </a:solidFill>
+                <a:latin typeface="Calibri"/>
+              </a:rPr>
+              <a:t>Kiremt</a:t>
+            </a:r>
+            <a:r>
+              <a:rPr sz="2800" b="0" i="0">
+                <a:solidFill>
+                  <a:srgbClr val="22252A"/>
+                </a:solidFill>
+                <a:latin typeface="Calibri"/>
+              </a:rPr>
+              <a:t> long rains (Jun to Sep). All 246 Addis filters in the public SPARTAN release give the same result.</a:t>
+            </a:r>
+          </a:p>
+        </p:txBody>
+      </p:sp>
+      <p:pic>
+        <p:nvPicPr>
+          <p:cNvPr id="17" name="Picture 16" descr="f0_network_map.png"/>
+          <p:cNvPicPr>
+            <a:picLocks noChangeAspect="1"/>
+          </p:cNvPicPr>
+          <p:nvPr/>
+        </p:nvPicPr>
+        <p:blipFill>
+          <a:blip r:embed="rId7"/>
+          <a:stretch>
+            <a:fillRect/>
+          </a:stretch>
+        </p:blipFill>
+        <p:spPr>
+          <a:xfrm>
+            <a:off x="2240280" y="13162280"/>
+            <a:ext cx="9601200" cy="4467084"/>
+          </a:xfrm>
+          <a:prstGeom prst="rect">
+            <a:avLst/>
+          </a:prstGeom>
+        </p:spPr>
+      </p:pic>
+      <p:sp>
+        <p:nvSpPr>
+          <p:cNvPr id="18" name="TextBox 17"/>
+          <p:cNvSpPr txBox="1"/>
+          <p:nvPr/>
+        </p:nvSpPr>
+        <p:spPr>
+          <a:xfrm>
+            <a:off x="1051560" y="17675084"/>
+            <a:ext cx="11978640" cy="896620"/>
+          </a:xfrm>
+          <a:prstGeom prst="rect">
+            <a:avLst/>
+          </a:prstGeom>
+          <a:noFill/>
+        </p:spPr>
+        <p:txBody>
+          <a:bodyPr wrap="square" tIns="27432" bIns="27432">
+            <a:spAutoFit/>
+          </a:bodyPr>
+          <a:lstStyle/>
+          <a:p>
+            <a:pPr algn="l">
+              <a:spcAft>
+                <a:spcPts val="460"/>
+              </a:spcAft>
+            </a:pPr>
+            <a:r>
+              <a:rPr sz="2300" b="1" i="0">
+                <a:solidFill>
+                  <a:srgbClr val="55585E"/>
+                </a:solidFill>
+                <a:latin typeface="Calibri"/>
+              </a:rPr>
+              <a:t>Figure 1.</a:t>
+            </a:r>
+            <a:r>
+              <a:rPr sz="2300" b="0" i="0">
+                <a:solidFill>
+                  <a:srgbClr val="55585E"/>
+                </a:solidFill>
+                <a:latin typeface="Calibri"/>
+              </a:rPr>
+              <a:t> Where the filters come from. Grey: IMPROVE sites (US), which provide the calibration. Blue stars: SPARTAN sites, where the calibration is applied.</a:t>
+            </a:r>
+          </a:p>
+        </p:txBody>
+      </p:sp>
+      <p:sp>
+        <p:nvSpPr>
+          <p:cNvPr id="19" name="Rectangle 18"/>
+          <p:cNvSpPr/>
+          <p:nvPr/>
+        </p:nvSpPr>
+        <p:spPr>
+          <a:xfrm>
+            <a:off x="777240" y="18800304"/>
+            <a:ext cx="12527280" cy="777240"/>
+          </a:xfrm>
+          <a:prstGeom prst="rect">
+            <a:avLst/>
+          </a:prstGeom>
+          <a:solidFill>
+            <a:srgbClr val="1B365D"/>
+          </a:solidFill>
+          <a:ln>
+            <a:noFill/>
+          </a:ln>
+          <a:effectLst/>
+        </p:spPr>
+        <p:style>
+          <a:lnRef idx="1">
+            <a:schemeClr val="accent1"/>
+          </a:lnRef>
+          <a:fillRef idx="3">
+            <a:schemeClr val="accent1"/>
+          </a:fillRef>
+          <a:effectRef idx="2">
+            <a:schemeClr val="accent1"/>
+          </a:effectRef>
+          <a:fontRef idx="minor">
+            <a:schemeClr val="lt1"/>
+          </a:fontRef>
+        </p:style>
+        <p:txBody>
+          <a:bodyPr rtlCol="0" anchor="ctr" lIns="182880"/>
+          <a:lstStyle/>
+          <a:p>
+            <a:pPr algn="ctr"/>
+            <a:r>
+              <a:rPr sz="3800" b="1" i="0">
+                <a:solidFill>
+                  <a:srgbClr val="FFFFFF"/>
+                </a:solidFill>
+                <a:latin typeface="Calibri"/>
+              </a:rPr>
               <a:t>How FTIR measures EC: a calibration</a:t>
             </a:r>
           </a:p>
@@ -3891,7 +3915,7 @@
       </p:sp>
       <p:sp>
         <p:nvSpPr>
-          <p:cNvPr id="19" name="TextBox 18"/>
+          <p:cNvPr id="20" name="TextBox 19"/>
           <p:cNvSpPr txBox="1"/>
           <p:nvPr/>
         </p:nvSpPr>
@@ -4027,7 +4051,7 @@
       </p:sp>
       <p:sp>
         <p:nvSpPr>
-          <p:cNvPr id="20" name="Rounded Rectangle 19"/>
+          <p:cNvPr id="21" name="Rounded Rectangle 20"/>
           <p:cNvSpPr/>
           <p:nvPr/>
         </p:nvSpPr>
@@ -4120,7 +4144,7 @@
       </p:sp>
       <p:sp>
         <p:nvSpPr>
-          <p:cNvPr id="21" name="Right Arrow 20"/>
+          <p:cNvPr id="22" name="Right Arrow 21"/>
           <p:cNvSpPr/>
           <p:nvPr/>
         </p:nvSpPr>
@@ -4164,7 +4188,7 @@
       </p:sp>
       <p:sp>
         <p:nvSpPr>
-          <p:cNvPr id="22" name="Right Arrow 21"/>
+          <p:cNvPr id="23" name="Right Arrow 22"/>
           <p:cNvSpPr/>
           <p:nvPr/>
         </p:nvSpPr>
@@ -4208,7 +4232,7 @@
       </p:sp>
       <p:sp>
         <p:nvSpPr>
-          <p:cNvPr id="23" name="Rounded Rectangle 22"/>
+          <p:cNvPr id="24" name="Rounded Rectangle 23"/>
           <p:cNvSpPr/>
           <p:nvPr/>
         </p:nvSpPr>
@@ -4286,7 +4310,7 @@
       </p:sp>
       <p:sp>
         <p:nvSpPr>
-          <p:cNvPr id="24" name="Rounded Rectangle 23"/>
+          <p:cNvPr id="25" name="Rounded Rectangle 24"/>
           <p:cNvSpPr/>
           <p:nvPr/>
         </p:nvSpPr>
@@ -4364,7 +4388,7 @@
       </p:sp>
       <p:sp>
         <p:nvSpPr>
-          <p:cNvPr id="25" name="Right Arrow 24"/>
+          <p:cNvPr id="26" name="Right Arrow 25"/>
           <p:cNvSpPr/>
           <p:nvPr/>
         </p:nvSpPr>
@@ -4408,7 +4432,7 @@
       </p:sp>
       <p:sp>
         <p:nvSpPr>
-          <p:cNvPr id="26" name="Right Arrow 25"/>
+          <p:cNvPr id="27" name="Right Arrow 26"/>
           <p:cNvSpPr/>
           <p:nvPr/>
         </p:nvSpPr>
@@ -4452,7 +4476,7 @@
       </p:sp>
       <p:sp>
         <p:nvSpPr>
-          <p:cNvPr id="27" name="Rounded Rectangle 26"/>
+          <p:cNvPr id="28" name="Rounded Rectangle 27"/>
           <p:cNvSpPr/>
           <p:nvPr/>
         </p:nvSpPr>
@@ -4545,7 +4569,7 @@
       </p:sp>
       <p:sp>
         <p:nvSpPr>
-          <p:cNvPr id="28" name="Down Arrow 27"/>
+          <p:cNvPr id="29" name="Down Arrow 28"/>
           <p:cNvSpPr/>
           <p:nvPr/>
         </p:nvSpPr>
@@ -4589,7 +4613,7 @@
       </p:sp>
       <p:sp>
         <p:nvSpPr>
-          <p:cNvPr id="29" name="Rounded Rectangle 28"/>
+          <p:cNvPr id="30" name="Rounded Rectangle 29"/>
           <p:cNvSpPr/>
           <p:nvPr/>
         </p:nvSpPr>
@@ -4682,7 +4706,7 @@
       </p:sp>
       <p:sp>
         <p:nvSpPr>
-          <p:cNvPr id="30" name="TextBox 29"/>
+          <p:cNvPr id="31" name="TextBox 30"/>
           <p:cNvSpPr txBox="1"/>
           <p:nvPr/>
         </p:nvSpPr>
@@ -4730,7 +4754,7 @@
       </p:sp>
       <p:sp>
         <p:nvSpPr>
-          <p:cNvPr id="31" name="Rectangle 30"/>
+          <p:cNvPr id="32" name="Rectangle 31"/>
           <p:cNvSpPr/>
           <p:nvPr/>
         </p:nvSpPr>
@@ -4776,7 +4800,7 @@
       </p:sp>
       <p:sp>
         <p:nvSpPr>
-          <p:cNvPr id="32" name="TextBox 31"/>
+          <p:cNvPr id="33" name="TextBox 32"/>
           <p:cNvSpPr txBox="1"/>
           <p:nvPr/>
         </p:nvSpPr>
@@ -4824,7 +4848,7 @@
       </p:sp>
       <p:sp>
         <p:nvSpPr>
-          <p:cNvPr id="33" name="Rectangle 32"/>
+          <p:cNvPr id="34" name="Rectangle 33"/>
           <p:cNvSpPr/>
           <p:nvPr/>
         </p:nvSpPr>
@@ -4877,7 +4901,7 @@
       </p:sp>
       <p:sp>
         <p:nvSpPr>
-          <p:cNvPr id="34" name="TextBox 33"/>
+          <p:cNvPr id="35" name="TextBox 34"/>
           <p:cNvSpPr txBox="1"/>
           <p:nvPr/>
         </p:nvSpPr>
@@ -5118,7 +5142,7 @@
       </p:sp>
       <p:sp>
         <p:nvSpPr>
-          <p:cNvPr id="35" name="TextBox 34"/>
+          <p:cNvPr id="36" name="TextBox 35"/>
           <p:cNvSpPr txBox="1"/>
           <p:nvPr/>
         </p:nvSpPr>
@@ -5166,7 +5190,7 @@
       </p:sp>
       <p:sp>
         <p:nvSpPr>
-          <p:cNvPr id="36" name="Rectangle 35"/>
+          <p:cNvPr id="37" name="Rectangle 36"/>
           <p:cNvSpPr/>
           <p:nvPr/>
         </p:nvSpPr>
@@ -5219,132 +5243,7 @@
       </p:sp>
       <p:pic>
         <p:nvPicPr>
-          <p:cNvPr id="37" name="Picture 36" descr="fp_addis_air.png"/>
-          <p:cNvPicPr>
-            <a:picLocks noChangeAspect="1"/>
-          </p:cNvPicPr>
-          <p:nvPr/>
-        </p:nvPicPr>
-        <p:blipFill>
-          <a:blip r:embed="rId7"/>
-          <a:stretch>
-            <a:fillRect/>
-          </a:stretch>
-        </p:blipFill>
-        <p:spPr>
-          <a:xfrm>
-            <a:off x="15956280" y="7406640"/>
-            <a:ext cx="8321040" cy="5134334"/>
-          </a:xfrm>
-          <a:prstGeom prst="rect">
-            <a:avLst/>
-          </a:prstGeom>
-        </p:spPr>
-      </p:pic>
-      <p:sp>
-        <p:nvSpPr>
-          <p:cNvPr id="38" name="TextBox 37"/>
-          <p:cNvSpPr txBox="1"/>
-          <p:nvPr/>
-        </p:nvSpPr>
-        <p:spPr>
-          <a:xfrm>
-            <a:off x="14127480" y="12586694"/>
-            <a:ext cx="11978640" cy="1247139"/>
-          </a:xfrm>
-          <a:prstGeom prst="rect">
-            <a:avLst/>
-          </a:prstGeom>
-          <a:noFill/>
-        </p:spPr>
-        <p:txBody>
-          <a:bodyPr wrap="square" tIns="27432" bIns="27432">
-            <a:spAutoFit/>
-          </a:bodyPr>
-          <a:lstStyle/>
-          <a:p>
-            <a:pPr algn="l">
-              <a:spcAft>
-                <a:spcPts val="460"/>
-              </a:spcAft>
-            </a:pPr>
-            <a:r>
-              <a:rPr sz="2300" b="1" i="0">
-                <a:solidFill>
-                  <a:srgbClr val="55585E"/>
-                </a:solidFill>
-                <a:latin typeface="Calibri"/>
-              </a:rPr>
-              <a:t>Figure 3.</a:t>
-            </a:r>
-            <a:r>
-              <a:rPr sz="2300" b="0" i="0">
-                <a:solidFill>
-                  <a:srgbClr val="55585E"/>
-                </a:solidFill>
-                <a:latin typeface="Calibri"/>
-              </a:rPr>
-              <a:t> Addis medians by season (bars on EC: interquartile range). EC is 4.3 to 5.6 µg/m³ and 19 to 25% of PM2.5 in every season, against about 4% for a typical IMPROVE filter.</a:t>
-            </a:r>
-          </a:p>
-        </p:txBody>
-      </p:sp>
-      <p:sp>
-        <p:nvSpPr>
-          <p:cNvPr id="39" name="Rectangle 38"/>
-          <p:cNvSpPr/>
-          <p:nvPr/>
-        </p:nvSpPr>
-        <p:spPr>
-          <a:xfrm>
-            <a:off x="13853159" y="14062434"/>
-            <a:ext cx="12527280" cy="777240"/>
-          </a:xfrm>
-          <a:prstGeom prst="rect">
-            <a:avLst/>
-          </a:prstGeom>
-          <a:solidFill>
-            <a:srgbClr val="1B365D"/>
-          </a:solidFill>
-          <a:ln>
-            <a:noFill/>
-          </a:ln>
-          <a:effectLst/>
-        </p:spPr>
-        <p:style>
-          <a:lnRef idx="1">
-            <a:schemeClr val="accent1"/>
-          </a:lnRef>
-          <a:fillRef idx="3">
-            <a:schemeClr val="accent1"/>
-          </a:fillRef>
-          <a:effectRef idx="2">
-            <a:schemeClr val="accent1"/>
-          </a:effectRef>
-          <a:fontRef idx="minor">
-            <a:schemeClr val="lt1"/>
-          </a:fontRef>
-        </p:style>
-        <p:txBody>
-          <a:bodyPr rtlCol="0" anchor="ctr" lIns="182880"/>
-          <a:lstStyle/>
-          <a:p>
-            <a:pPr algn="ctr"/>
-            <a:r>
-              <a:rPr sz="3800" b="1" i="0">
-                <a:solidFill>
-                  <a:srgbClr val="FFFFFF"/>
-                </a:solidFill>
-                <a:latin typeface="Calibri"/>
-              </a:rPr>
-              <a:t>The problem: FTIR EC is poorly predicted but well correlated</a:t>
-            </a:r>
-          </a:p>
-        </p:txBody>
-      </p:sp>
-      <p:pic>
-        <p:nvPicPr>
-          <p:cNvPr id="40" name="Picture 39" descr="fp_problem.png"/>
+          <p:cNvPr id="38" name="Picture 37" descr="fp_addis_air.png"/>
           <p:cNvPicPr>
             <a:picLocks noChangeAspect="1"/>
           </p:cNvPicPr>
@@ -5358,8 +5257,8 @@
         </p:blipFill>
         <p:spPr>
           <a:xfrm>
-            <a:off x="14127480" y="15022554"/>
-            <a:ext cx="11978640" cy="5980830"/>
+            <a:off x="15956280" y="7406640"/>
+            <a:ext cx="8321040" cy="5134334"/>
           </a:xfrm>
           <a:prstGeom prst="rect">
             <a:avLst/>
@@ -5368,14 +5267,14 @@
       </p:pic>
       <p:sp>
         <p:nvSpPr>
-          <p:cNvPr id="41" name="TextBox 40"/>
+          <p:cNvPr id="39" name="TextBox 38"/>
           <p:cNvSpPr txBox="1"/>
           <p:nvPr/>
         </p:nvSpPr>
         <p:spPr>
           <a:xfrm>
-            <a:off x="14127480" y="21049105"/>
-            <a:ext cx="11978640" cy="1948180"/>
+            <a:off x="14127480" y="12586694"/>
+            <a:ext cx="11978640" cy="1247139"/>
           </a:xfrm>
           <a:prstGeom prst="rect">
             <a:avLst/>
@@ -5400,7 +5299,7 @@
                 </a:solidFill>
                 <a:latin typeface="Calibri"/>
               </a:rPr>
-              <a:t>Figure 4.</a:t>
+              <a:t>Figure 3.</a:t>
             </a:r>
             <a:r>
               <a:rPr sz="2300" b="0" i="0">
@@ -5409,56 +5308,20 @@
                 </a:solidFill>
                 <a:latin typeface="Calibri"/>
               </a:rPr>
-              <a:t> Each point is one filter; dotted line: 1:1. </a:t>
-            </a:r>
-            <a:r>
-              <a:rPr sz="2300" b="1" i="0">
-                <a:solidFill>
-                  <a:srgbClr val="55585E"/>
-                </a:solidFill>
-                <a:latin typeface="Calibri"/>
-              </a:rPr>
-              <a:t>IMPROVE:</a:t>
-            </a:r>
-            <a:r>
-              <a:rPr sz="2300" b="0" i="0">
-                <a:solidFill>
-                  <a:srgbClr val="55585E"/>
-                </a:solidFill>
-                <a:latin typeface="Calibri"/>
-              </a:rPr>
-              <a:t> 2,078 filters, FTIR against TOR EC: slope near 1, intercept near 0. </a:t>
-            </a:r>
-            <a:r>
-              <a:rPr sz="2300" b="1" i="0">
-                <a:solidFill>
-                  <a:srgbClr val="55585E"/>
-                </a:solidFill>
-                <a:latin typeface="Calibri"/>
-              </a:rPr>
-              <a:t>SPARTAN:</a:t>
-            </a:r>
-            <a:r>
-              <a:rPr sz="2300" b="0" i="0">
-                <a:solidFill>
-                  <a:srgbClr val="55585E"/>
-                </a:solidFill>
-                <a:latin typeface="Calibri"/>
-              </a:rPr>
-              <a:t> FTIR against HIPS EC. The other SPARTAN sites together are predicted reasonably (grey line), and Addis sits inside that cloud, but Addis alone is well correlated with the wrong slope and intercept (2.3x -6.1). Every season is off (slopes 1.4 to 2.2).</a:t>
-            </a:r>
-          </a:p>
-        </p:txBody>
-      </p:sp>
-      <p:sp>
-        <p:nvSpPr>
-          <p:cNvPr id="42" name="Rectangle 41"/>
+              <a:t> Addis medians by season (bars on EC: interquartile range). EC is 4.3 to 5.6 µg/m³ and 19 to 25% of PM2.5 in every season, against about 4% for a typical IMPROVE filter.</a:t>
+            </a:r>
+          </a:p>
+        </p:txBody>
+      </p:sp>
+      <p:sp>
+        <p:nvSpPr>
+          <p:cNvPr id="40" name="Rectangle 39"/>
           <p:cNvSpPr/>
           <p:nvPr/>
         </p:nvSpPr>
         <p:spPr>
           <a:xfrm>
-            <a:off x="13853159" y="23225885"/>
+            <a:off x="13853159" y="14062434"/>
             <a:ext cx="12527280" cy="777240"/>
           </a:xfrm>
           <a:prstGeom prst="rect">
@@ -5498,71 +5361,14 @@
                 </a:solidFill>
                 <a:latin typeface="Calibri"/>
               </a:rPr>
-              <a:t>IMPROVE filters that look like Addis fail too</a:t>
-            </a:r>
-          </a:p>
-        </p:txBody>
-      </p:sp>
-      <p:sp>
-        <p:nvSpPr>
-          <p:cNvPr id="43" name="TextBox 42"/>
-          <p:cNvSpPr txBox="1"/>
-          <p:nvPr/>
-        </p:nvSpPr>
-        <p:spPr>
-          <a:xfrm>
-            <a:off x="14127480" y="24186005"/>
-            <a:ext cx="11978640" cy="1045209"/>
-          </a:xfrm>
-          <a:prstGeom prst="rect">
-            <a:avLst/>
-          </a:prstGeom>
-          <a:noFill/>
-        </p:spPr>
-        <p:txBody>
-          <a:bodyPr wrap="square" tIns="27432" bIns="27432">
-            <a:spAutoFit/>
-          </a:bodyPr>
-          <a:lstStyle/>
-          <a:p>
-            <a:pPr algn="l">
-              <a:spcAft>
-                <a:spcPts val="910"/>
-              </a:spcAft>
-            </a:pPr>
-            <a:r>
-              <a:rPr sz="2600" b="0" i="0">
-                <a:solidFill>
-                  <a:srgbClr val="22252A"/>
-                </a:solidFill>
-                <a:latin typeface="Calibri"/>
-              </a:rPr>
-              <a:t>From the IMPROVE filters we picked the 97 whose </a:t>
-            </a:r>
-            <a:r>
-              <a:rPr sz="2600" b="1" i="0">
-                <a:solidFill>
-                  <a:srgbClr val="22252A"/>
-                </a:solidFill>
-                <a:latin typeface="Calibri"/>
-              </a:rPr>
-              <a:t>spectra most resemble the Addis spectra</a:t>
-            </a:r>
-            <a:r>
-              <a:rPr sz="2600" b="0" i="0">
-                <a:solidFill>
-                  <a:srgbClr val="22252A"/>
-                </a:solidFill>
-                <a:latin typeface="Calibri"/>
-              </a:rPr>
-              <a:t>. Many are smoke-affected.</a:t>
+              <a:t>The problem: FTIR EC is poorly predicted but well correlated</a:t>
             </a:r>
           </a:p>
         </p:txBody>
       </p:sp>
       <p:pic>
         <p:nvPicPr>
-          <p:cNvPr id="44" name="Picture 43" descr="fp_analogs.png"/>
+          <p:cNvPr id="41" name="Picture 40" descr="fp_problem.png"/>
           <p:cNvPicPr>
             <a:picLocks noChangeAspect="1"/>
           </p:cNvPicPr>
@@ -5576,7 +5382,7 @@
         </p:blipFill>
         <p:spPr>
           <a:xfrm>
-            <a:off x="14127480" y="25276935"/>
+            <a:off x="14127480" y="15022554"/>
             <a:ext cx="11978640" cy="5980830"/>
           </a:xfrm>
           <a:prstGeom prst="rect">
@@ -5586,14 +5392,14 @@
       </p:pic>
       <p:sp>
         <p:nvSpPr>
-          <p:cNvPr id="45" name="TextBox 44"/>
+          <p:cNvPr id="42" name="TextBox 41"/>
           <p:cNvSpPr txBox="1"/>
           <p:nvPr/>
         </p:nvSpPr>
         <p:spPr>
           <a:xfrm>
-            <a:off x="14127480" y="31303485"/>
-            <a:ext cx="11978640" cy="1247139"/>
+            <a:off x="14127480" y="21049105"/>
+            <a:ext cx="11978640" cy="1948180"/>
           </a:xfrm>
           <a:prstGeom prst="rect">
             <a:avLst/>
@@ -5618,7 +5424,7 @@
                 </a:solidFill>
                 <a:latin typeface="Calibri"/>
               </a:rPr>
-              <a:t>Figure 5.</a:t>
+              <a:t>Figure 4.</a:t>
             </a:r>
             <a:r>
               <a:rPr sz="2300" b="0" i="0">
@@ -5627,20 +5433,56 @@
                 </a:solidFill>
                 <a:latin typeface="Calibri"/>
               </a:rPr>
-              <a:t> Grey: all IMPROVE filters; red: the 97 most like Addis. TOR and HIPS agree on them, but the same FTIR calibration predicts them poorly, at ordinary IMPROVE concentrations. Same calibration; only the samples changed.</a:t>
-            </a:r>
-          </a:p>
-        </p:txBody>
-      </p:sp>
-      <p:sp>
-        <p:nvSpPr>
-          <p:cNvPr id="46" name="Rectangle 45"/>
+              <a:t> Each point is one filter; dotted line: 1:1. </a:t>
+            </a:r>
+            <a:r>
+              <a:rPr sz="2300" b="1" i="0">
+                <a:solidFill>
+                  <a:srgbClr val="55585E"/>
+                </a:solidFill>
+                <a:latin typeface="Calibri"/>
+              </a:rPr>
+              <a:t>IMPROVE:</a:t>
+            </a:r>
+            <a:r>
+              <a:rPr sz="2300" b="0" i="0">
+                <a:solidFill>
+                  <a:srgbClr val="55585E"/>
+                </a:solidFill>
+                <a:latin typeface="Calibri"/>
+              </a:rPr>
+              <a:t> 2,078 filters, FTIR against TOR EC: slope near 1, intercept near 0. </a:t>
+            </a:r>
+            <a:r>
+              <a:rPr sz="2300" b="1" i="0">
+                <a:solidFill>
+                  <a:srgbClr val="55585E"/>
+                </a:solidFill>
+                <a:latin typeface="Calibri"/>
+              </a:rPr>
+              <a:t>SPARTAN:</a:t>
+            </a:r>
+            <a:r>
+              <a:rPr sz="2300" b="0" i="0">
+                <a:solidFill>
+                  <a:srgbClr val="55585E"/>
+                </a:solidFill>
+                <a:latin typeface="Calibri"/>
+              </a:rPr>
+              <a:t> FTIR against HIPS EC. The other SPARTAN sites together are predicted reasonably (grey line), and Addis sits inside that cloud, but Addis alone is well correlated with the wrong slope and intercept (2.3x -6.1). Every season is off (slopes 1.4 to 2.2).</a:t>
+            </a:r>
+          </a:p>
+        </p:txBody>
+      </p:sp>
+      <p:sp>
+        <p:nvSpPr>
+          <p:cNvPr id="43" name="Rectangle 42"/>
           <p:cNvSpPr/>
           <p:nvPr/>
         </p:nvSpPr>
         <p:spPr>
           <a:xfrm>
-            <a:off x="13853159" y="32779225"/>
+            <a:off x="13853159" y="23225885"/>
             <a:ext cx="12527280" cy="777240"/>
           </a:xfrm>
           <a:prstGeom prst="rect">
@@ -5680,14 +5522,71 @@
                 </a:solidFill>
                 <a:latin typeface="Calibri"/>
               </a:rPr>
-              <a:t>Addis filters carry far more EC than IMPROVE filters</a:t>
+              <a:t>IMPROVE filters that look like Addis fail too</a:t>
+            </a:r>
+          </a:p>
+        </p:txBody>
+      </p:sp>
+      <p:sp>
+        <p:nvSpPr>
+          <p:cNvPr id="44" name="TextBox 43"/>
+          <p:cNvSpPr txBox="1"/>
+          <p:nvPr/>
+        </p:nvSpPr>
+        <p:spPr>
+          <a:xfrm>
+            <a:off x="14127480" y="24186005"/>
+            <a:ext cx="11978640" cy="1045209"/>
+          </a:xfrm>
+          <a:prstGeom prst="rect">
+            <a:avLst/>
+          </a:prstGeom>
+          <a:noFill/>
+        </p:spPr>
+        <p:txBody>
+          <a:bodyPr wrap="square" tIns="27432" bIns="27432">
+            <a:spAutoFit/>
+          </a:bodyPr>
+          <a:lstStyle/>
+          <a:p>
+            <a:pPr algn="l">
+              <a:spcAft>
+                <a:spcPts val="910"/>
+              </a:spcAft>
+            </a:pPr>
+            <a:r>
+              <a:rPr sz="2600" b="0" i="0">
+                <a:solidFill>
+                  <a:srgbClr val="22252A"/>
+                </a:solidFill>
+                <a:latin typeface="Calibri"/>
+              </a:rPr>
+              <a:t>From the IMPROVE filters we picked the 97 whose </a:t>
+            </a:r>
+            <a:r>
+              <a:rPr sz="2600" b="1" i="0">
+                <a:solidFill>
+                  <a:srgbClr val="22252A"/>
+                </a:solidFill>
+                <a:latin typeface="Calibri"/>
+              </a:rPr>
+              <a:t>spectra most resemble the Addis spectra</a:t>
+            </a:r>
+            <a:r>
+              <a:rPr sz="2600" b="0" i="0">
+                <a:solidFill>
+                  <a:srgbClr val="22252A"/>
+                </a:solidFill>
+                <a:latin typeface="Calibri"/>
+              </a:rPr>
+              <a:t>. Many are smoke-affected.</a:t>
             </a:r>
           </a:p>
         </p:txBody>
       </p:sp>
       <p:pic>
         <p:nvPicPr>
-          <p:cNvPr id="47" name="Picture 46" descr="fp_loading.png"/>
+          <p:cNvPr id="45" name="Picture 44" descr="fp_analogs.png"/>
           <p:cNvPicPr>
             <a:picLocks noChangeAspect="1"/>
           </p:cNvPicPr>
@@ -5701,8 +5600,8 @@
         </p:blipFill>
         <p:spPr>
           <a:xfrm>
-            <a:off x="14493240" y="33739345"/>
-            <a:ext cx="11247119" cy="4927726"/>
+            <a:off x="14127480" y="25276935"/>
+            <a:ext cx="11978640" cy="5980830"/>
           </a:xfrm>
           <a:prstGeom prst="rect">
             <a:avLst/>
@@ -5711,13 +5610,13 @@
       </p:pic>
       <p:sp>
         <p:nvSpPr>
-          <p:cNvPr id="48" name="TextBox 47"/>
+          <p:cNvPr id="46" name="TextBox 45"/>
           <p:cNvSpPr txBox="1"/>
           <p:nvPr/>
         </p:nvSpPr>
         <p:spPr>
           <a:xfrm>
-            <a:off x="14127480" y="38712792"/>
+            <a:off x="14127480" y="31303485"/>
             <a:ext cx="11978640" cy="1247139"/>
           </a:xfrm>
           <a:prstGeom prst="rect">
@@ -5743,7 +5642,7 @@
                 </a:solidFill>
                 <a:latin typeface="Calibri"/>
               </a:rPr>
-              <a:t>Figure 6.</a:t>
+              <a:t>Figure 5.</a:t>
             </a:r>
             <a:r>
               <a:rPr sz="2300" b="0" i="0">
@@ -5752,20 +5651,20 @@
                 </a:solidFill>
                 <a:latin typeface="Calibri"/>
               </a:rPr>
-              <a:t> EC on one filter, from each filter's own volume of air (flow × sampling time). The typical Addis filter carries about 9× the EC of a typical IMPROVE calibration filter, and 79% are above the IMPROVE 99th percentile.</a:t>
-            </a:r>
-          </a:p>
-        </p:txBody>
-      </p:sp>
-      <p:sp>
-        <p:nvSpPr>
-          <p:cNvPr id="49" name="Rectangle 48"/>
+              <a:t> Grey: all IMPROVE filters; red: the 97 most like Addis. TOR and HIPS agree on them, but the same FTIR calibration predicts them poorly, at ordinary IMPROVE concentrations. Same calibration; only the samples changed.</a:t>
+            </a:r>
+          </a:p>
+        </p:txBody>
+      </p:sp>
+      <p:sp>
+        <p:nvSpPr>
+          <p:cNvPr id="47" name="Rectangle 46"/>
           <p:cNvSpPr/>
           <p:nvPr/>
         </p:nvSpPr>
         <p:spPr>
           <a:xfrm>
-            <a:off x="26929080" y="6446520"/>
+            <a:off x="13853159" y="32779225"/>
             <a:ext cx="12527280" cy="777240"/>
           </a:xfrm>
           <a:prstGeom prst="rect">
@@ -5805,62 +5704,14 @@
                 </a:solidFill>
                 <a:latin typeface="Calibri"/>
               </a:rPr>
-              <a:t>Toward a better calibration (work in progress)</a:t>
-            </a:r>
-          </a:p>
-        </p:txBody>
-      </p:sp>
-      <p:sp>
-        <p:nvSpPr>
-          <p:cNvPr id="50" name="TextBox 49"/>
-          <p:cNvSpPr txBox="1"/>
-          <p:nvPr/>
-        </p:nvSpPr>
-        <p:spPr>
-          <a:xfrm>
-            <a:off x="27203400" y="7406640"/>
-            <a:ext cx="11978640" cy="648970"/>
-          </a:xfrm>
-          <a:prstGeom prst="rect">
-            <a:avLst/>
-          </a:prstGeom>
-          <a:noFill/>
-        </p:spPr>
-        <p:txBody>
-          <a:bodyPr wrap="square" tIns="27432" bIns="27432">
-            <a:spAutoFit/>
-          </a:bodyPr>
-          <a:lstStyle/>
-          <a:p>
-            <a:pPr algn="l">
-              <a:spcAft>
-                <a:spcPts val="910"/>
-              </a:spcAft>
-            </a:pPr>
-            <a:r>
-              <a:rPr sz="2600" b="1" i="0">
-                <a:solidFill>
-                  <a:srgbClr val="22252A"/>
-                </a:solidFill>
-                <a:latin typeface="Calibri"/>
-              </a:rPr>
-              <a:t>Step 1. Baseline correction of the spectra</a:t>
-            </a:r>
-            <a:r>
-              <a:rPr sz="2600" b="0" i="0">
-                <a:solidFill>
-                  <a:srgbClr val="22252A"/>
-                </a:solidFill>
-                <a:latin typeface="Calibri"/>
-              </a:rPr>
-              <a:t>, the biggest gain so far.</a:t>
+              <a:t>Addis filters carry far more EC than IMPROVE filters</a:t>
             </a:r>
           </a:p>
         </p:txBody>
       </p:sp>
       <p:pic>
         <p:nvPicPr>
-          <p:cNvPr id="51" name="Picture 50" descr="fp_baseline.png"/>
+          <p:cNvPr id="48" name="Picture 47" descr="fp_loading.png"/>
           <p:cNvPicPr>
             <a:picLocks noChangeAspect="1"/>
           </p:cNvPicPr>
@@ -5874,8 +5725,8 @@
         </p:blipFill>
         <p:spPr>
           <a:xfrm>
-            <a:off x="27203400" y="8101330"/>
-            <a:ext cx="11978640" cy="6035683"/>
+            <a:off x="14493240" y="33739345"/>
+            <a:ext cx="11247119" cy="4927726"/>
           </a:xfrm>
           <a:prstGeom prst="rect">
             <a:avLst/>
@@ -5884,14 +5735,14 @@
       </p:pic>
       <p:sp>
         <p:nvSpPr>
-          <p:cNvPr id="52" name="TextBox 51"/>
+          <p:cNvPr id="49" name="TextBox 48"/>
           <p:cNvSpPr txBox="1"/>
           <p:nvPr/>
         </p:nvSpPr>
         <p:spPr>
           <a:xfrm>
-            <a:off x="27203400" y="14182733"/>
-            <a:ext cx="11978640" cy="896620"/>
+            <a:off x="14127480" y="38712792"/>
+            <a:ext cx="11978640" cy="1247139"/>
           </a:xfrm>
           <a:prstGeom prst="rect">
             <a:avLst/>
@@ -5916,7 +5767,7 @@
                 </a:solidFill>
                 <a:latin typeface="Calibri"/>
               </a:rPr>
-              <a:t>Figure 7.</a:t>
+              <a:t>Figure 6.</a:t>
             </a:r>
             <a:r>
               <a:rPr sz="2300" b="0" i="0">
@@ -5925,21 +5776,74 @@
                 </a:solidFill>
                 <a:latin typeface="Calibri"/>
               </a:rPr>
-              <a:t> Same Addis filters, same axes as Figure 4. Correcting the baseline moves the intercept from -6.1 to -1.2 µg/m³, but the slope drops to 0.59.</a:t>
-            </a:r>
-          </a:p>
-        </p:txBody>
-      </p:sp>
-      <p:sp>
-        <p:nvSpPr>
-          <p:cNvPr id="53" name="TextBox 52"/>
+              <a:t> EC on one filter, from each filter's own volume of air (flow × sampling time). The typical Addis filter carries about 9× the EC of a typical IMPROVE calibration filter, and 79% are above the IMPROVE 99th percentile.</a:t>
+            </a:r>
+          </a:p>
+        </p:txBody>
+      </p:sp>
+      <p:sp>
+        <p:nvSpPr>
+          <p:cNvPr id="50" name="Rectangle 49"/>
+          <p:cNvSpPr/>
+          <p:nvPr/>
+        </p:nvSpPr>
+        <p:spPr>
+          <a:xfrm>
+            <a:off x="26929080" y="6446520"/>
+            <a:ext cx="12527280" cy="777240"/>
+          </a:xfrm>
+          <a:prstGeom prst="rect">
+            <a:avLst/>
+          </a:prstGeom>
+          <a:solidFill>
+            <a:srgbClr val="1B365D"/>
+          </a:solidFill>
+          <a:ln>
+            <a:noFill/>
+          </a:ln>
+          <a:effectLst/>
+        </p:spPr>
+        <p:style>
+          <a:lnRef idx="1">
+            <a:schemeClr val="accent1"/>
+          </a:lnRef>
+          <a:fillRef idx="3">
+            <a:schemeClr val="accent1"/>
+          </a:fillRef>
+          <a:effectRef idx="2">
+            <a:schemeClr val="accent1"/>
+          </a:effectRef>
+          <a:fontRef idx="minor">
+            <a:schemeClr val="lt1"/>
+          </a:fontRef>
+        </p:style>
+        <p:txBody>
+          <a:bodyPr rtlCol="0" anchor="ctr" lIns="182880"/>
+          <a:lstStyle/>
+          <a:p>
+            <a:pPr algn="ctr"/>
+            <a:r>
+              <a:rPr sz="3800" b="1" i="0">
+                <a:solidFill>
+                  <a:srgbClr val="FFFFFF"/>
+                </a:solidFill>
+                <a:latin typeface="Calibri"/>
+              </a:rPr>
+              <a:t>Toward a better calibration (work in progress)</a:t>
+            </a:r>
+          </a:p>
+        </p:txBody>
+      </p:sp>
+      <p:sp>
+        <p:nvSpPr>
+          <p:cNvPr id="51" name="TextBox 50"/>
           <p:cNvSpPr txBox="1"/>
           <p:nvPr/>
         </p:nvSpPr>
         <p:spPr>
           <a:xfrm>
-            <a:off x="27203400" y="15262233"/>
-            <a:ext cx="11978640" cy="1045209"/>
+            <a:off x="27203400" y="7406640"/>
+            <a:ext cx="11978640" cy="648970"/>
           </a:xfrm>
           <a:prstGeom prst="rect">
             <a:avLst/>
@@ -5964,7 +5868,7 @@
                 </a:solidFill>
                 <a:latin typeface="Calibri"/>
               </a:rPr>
-              <a:t>Step 2. Test thousands of calibrations</a:t>
+              <a:t>Step 1. Baseline correction of the spectra</a:t>
             </a:r>
             <a:r>
               <a:rPr sz="2600" b="0" i="0">
@@ -5973,14 +5877,14 @@
                 </a:solidFill>
                 <a:latin typeface="Calibri"/>
               </a:rPr>
-              <a:t> with an interactive app we built, changing which IMPROVE filters are in the calibration set and how it is built.</a:t>
+              <a:t>, the biggest gain so far.</a:t>
             </a:r>
           </a:p>
         </p:txBody>
       </p:sp>
       <p:pic>
         <p:nvPicPr>
-          <p:cNvPr id="54" name="Picture 53" descr="fp_explorer.png"/>
+          <p:cNvPr id="52" name="Picture 51" descr="fp_baseline.png"/>
           <p:cNvPicPr>
             <a:picLocks noChangeAspect="1"/>
           </p:cNvPicPr>
@@ -5994,8 +5898,8 @@
         </p:blipFill>
         <p:spPr>
           <a:xfrm>
-            <a:off x="27203400" y="16353163"/>
-            <a:ext cx="11978640" cy="5398775"/>
+            <a:off x="27203400" y="8101330"/>
+            <a:ext cx="11978640" cy="6035683"/>
           </a:xfrm>
           <a:prstGeom prst="rect">
             <a:avLst/>
@@ -6004,14 +5908,14 @@
       </p:pic>
       <p:sp>
         <p:nvSpPr>
-          <p:cNvPr id="55" name="TextBox 54"/>
+          <p:cNvPr id="53" name="TextBox 52"/>
           <p:cNvSpPr txBox="1"/>
           <p:nvPr/>
         </p:nvSpPr>
         <p:spPr>
           <a:xfrm>
-            <a:off x="27203400" y="21797658"/>
-            <a:ext cx="11978640" cy="1597659"/>
+            <a:off x="27203400" y="14182733"/>
+            <a:ext cx="11978640" cy="896620"/>
           </a:xfrm>
           <a:prstGeom prst="rect">
             <a:avLst/>
@@ -6036,7 +5940,7 @@
                 </a:solidFill>
                 <a:latin typeface="Calibri"/>
               </a:rPr>
-              <a:t>Figure 8.</a:t>
+              <a:t>Figure 7.</a:t>
             </a:r>
             <a:r>
               <a:rPr sz="2300" b="0" i="0">
@@ -6045,20 +5949,20 @@
                 </a:solidFill>
                 <a:latin typeface="Calibri"/>
               </a:rPr>
-              <a:t> Each column is one calibration (3,138, all on baseline-corrected spectra), sorted by its Addis intercept (top). Tick marks show which choices it used. 254 put the intercept within ±0.5 µg/m³ of zero; 20 of those also have a slope between 0.8 and 1.25. Next: find out why those work, or whether it is chance.</a:t>
-            </a:r>
-          </a:p>
-        </p:txBody>
-      </p:sp>
-      <p:sp>
-        <p:nvSpPr>
-          <p:cNvPr id="56" name="TextBox 55"/>
+              <a:t> Same Addis filters, same axes as Figure 4. Correcting the baseline moves the intercept from -6.1 to -1.2 µg/m³, but the slope drops to 0.59.</a:t>
+            </a:r>
+          </a:p>
+        </p:txBody>
+      </p:sp>
+      <p:sp>
+        <p:nvSpPr>
+          <p:cNvPr id="54" name="TextBox 53"/>
           <p:cNvSpPr txBox="1"/>
           <p:nvPr/>
         </p:nvSpPr>
         <p:spPr>
           <a:xfrm>
-            <a:off x="27203400" y="23578198"/>
+            <a:off x="27203400" y="15262233"/>
             <a:ext cx="11978640" cy="1045209"/>
           </a:xfrm>
           <a:prstGeom prst="rect">
@@ -6084,7 +5988,7 @@
                 </a:solidFill>
                 <a:latin typeface="Calibri"/>
               </a:rPr>
-              <a:t>Step 3. One calibration per season</a:t>
+              <a:t>Step 2. Test thousands of calibrations</a:t>
             </a:r>
             <a:r>
               <a:rPr sz="2600" b="0" i="0">
@@ -6093,14 +5997,14 @@
                 </a:solidFill>
                 <a:latin typeface="Calibri"/>
               </a:rPr>
-              <a:t>, built from the IMPROVE filters whose spectra most resemble that season's Addis spectra.</a:t>
+              <a:t> with an interactive app we built, changing which IMPROVE filters are in the calibration set and how it is built.</a:t>
             </a:r>
           </a:p>
         </p:txBody>
       </p:sp>
       <p:pic>
         <p:nvPicPr>
-          <p:cNvPr id="57" name="Picture 56" descr="fp_seasons.png"/>
+          <p:cNvPr id="55" name="Picture 54" descr="fp_explorer.png"/>
           <p:cNvPicPr>
             <a:picLocks noChangeAspect="1"/>
           </p:cNvPicPr>
@@ -6114,8 +6018,8 @@
         </p:blipFill>
         <p:spPr>
           <a:xfrm>
-            <a:off x="27203400" y="24669128"/>
-            <a:ext cx="11978640" cy="5192898"/>
+            <a:off x="27203400" y="16353163"/>
+            <a:ext cx="11978640" cy="5398775"/>
           </a:xfrm>
           <a:prstGeom prst="rect">
             <a:avLst/>
@@ -6124,14 +6028,14 @@
       </p:pic>
       <p:sp>
         <p:nvSpPr>
-          <p:cNvPr id="58" name="TextBox 57"/>
+          <p:cNvPr id="56" name="TextBox 55"/>
           <p:cNvSpPr txBox="1"/>
           <p:nvPr/>
         </p:nvSpPr>
         <p:spPr>
           <a:xfrm>
-            <a:off x="27203400" y="29907747"/>
-            <a:ext cx="11978640" cy="896620"/>
+            <a:off x="27203400" y="21797658"/>
+            <a:ext cx="11978640" cy="1597659"/>
           </a:xfrm>
           <a:prstGeom prst="rect">
             <a:avLst/>
@@ -6156,6 +6060,126 @@
                 </a:solidFill>
                 <a:latin typeface="Calibri"/>
               </a:rPr>
+              <a:t>Figure 8.</a:t>
+            </a:r>
+            <a:r>
+              <a:rPr sz="2300" b="0" i="0">
+                <a:solidFill>
+                  <a:srgbClr val="55585E"/>
+                </a:solidFill>
+                <a:latin typeface="Calibri"/>
+              </a:rPr>
+              <a:t> Each column is one calibration (3,138, all on baseline-corrected spectra), sorted by its Addis intercept (top). Tick marks show which choices it used. 254 put the intercept within ±0.5 µg/m³ of zero; 20 of those also have a slope between 0.8 and 1.25. Next: find out why those work, or whether it is chance.</a:t>
+            </a:r>
+          </a:p>
+        </p:txBody>
+      </p:sp>
+      <p:sp>
+        <p:nvSpPr>
+          <p:cNvPr id="57" name="TextBox 56"/>
+          <p:cNvSpPr txBox="1"/>
+          <p:nvPr/>
+        </p:nvSpPr>
+        <p:spPr>
+          <a:xfrm>
+            <a:off x="27203400" y="23578198"/>
+            <a:ext cx="11978640" cy="1045209"/>
+          </a:xfrm>
+          <a:prstGeom prst="rect">
+            <a:avLst/>
+          </a:prstGeom>
+          <a:noFill/>
+        </p:spPr>
+        <p:txBody>
+          <a:bodyPr wrap="square" tIns="27432" bIns="27432">
+            <a:spAutoFit/>
+          </a:bodyPr>
+          <a:lstStyle/>
+          <a:p>
+            <a:pPr algn="l">
+              <a:spcAft>
+                <a:spcPts val="910"/>
+              </a:spcAft>
+            </a:pPr>
+            <a:r>
+              <a:rPr sz="2600" b="1" i="0">
+                <a:solidFill>
+                  <a:srgbClr val="22252A"/>
+                </a:solidFill>
+                <a:latin typeface="Calibri"/>
+              </a:rPr>
+              <a:t>Step 3. One calibration per season</a:t>
+            </a:r>
+            <a:r>
+              <a:rPr sz="2600" b="0" i="0">
+                <a:solidFill>
+                  <a:srgbClr val="22252A"/>
+                </a:solidFill>
+                <a:latin typeface="Calibri"/>
+              </a:rPr>
+              <a:t>, built from the IMPROVE filters whose spectra most resemble that season's Addis spectra.</a:t>
+            </a:r>
+          </a:p>
+        </p:txBody>
+      </p:sp>
+      <p:pic>
+        <p:nvPicPr>
+          <p:cNvPr id="58" name="Picture 57" descr="fp_seasons.png"/>
+          <p:cNvPicPr>
+            <a:picLocks noChangeAspect="1"/>
+          </p:cNvPicPr>
+          <p:nvPr/>
+        </p:nvPicPr>
+        <p:blipFill>
+          <a:blip r:embed="rId14"/>
+          <a:stretch>
+            <a:fillRect/>
+          </a:stretch>
+        </p:blipFill>
+        <p:spPr>
+          <a:xfrm>
+            <a:off x="27203400" y="24669128"/>
+            <a:ext cx="11978640" cy="5192898"/>
+          </a:xfrm>
+          <a:prstGeom prst="rect">
+            <a:avLst/>
+          </a:prstGeom>
+        </p:spPr>
+      </p:pic>
+      <p:sp>
+        <p:nvSpPr>
+          <p:cNvPr id="59" name="TextBox 58"/>
+          <p:cNvSpPr txBox="1"/>
+          <p:nvPr/>
+        </p:nvSpPr>
+        <p:spPr>
+          <a:xfrm>
+            <a:off x="27203400" y="29907747"/>
+            <a:ext cx="11978640" cy="896620"/>
+          </a:xfrm>
+          <a:prstGeom prst="rect">
+            <a:avLst/>
+          </a:prstGeom>
+          <a:noFill/>
+        </p:spPr>
+        <p:txBody>
+          <a:bodyPr wrap="square" tIns="27432" bIns="27432">
+            <a:spAutoFit/>
+          </a:bodyPr>
+          <a:lstStyle/>
+          <a:p>
+            <a:pPr algn="l">
+              <a:spcAft>
+                <a:spcPts val="460"/>
+              </a:spcAft>
+            </a:pPr>
+            <a:r>
+              <a:rPr sz="2300" b="1" i="0">
+                <a:solidFill>
+                  <a:srgbClr val="55585E"/>
+                </a:solidFill>
+                <a:latin typeface="Calibri"/>
+              </a:rPr>
               <a:t>Figure 9.</a:t>
             </a:r>
             <a:r>
@@ -6172,7 +6196,7 @@
       </p:sp>
       <p:sp>
         <p:nvSpPr>
-          <p:cNvPr id="59" name="Rectangle 58"/>
+          <p:cNvPr id="60" name="Rectangle 59"/>
           <p:cNvSpPr/>
           <p:nvPr/>
         </p:nvSpPr>
@@ -6225,7 +6249,7 @@
       </p:sp>
       <p:sp>
         <p:nvSpPr>
-          <p:cNvPr id="60" name="TextBox 59"/>
+          <p:cNvPr id="61" name="TextBox 60"/>
           <p:cNvSpPr txBox="1"/>
           <p:nvPr/>
         </p:nvSpPr>
@@ -6299,7 +6323,7 @@
       </p:sp>
       <p:sp>
         <p:nvSpPr>
-          <p:cNvPr id="61" name="Rectangle 60"/>
+          <p:cNvPr id="62" name="Rectangle 61"/>
           <p:cNvSpPr/>
           <p:nvPr/>
         </p:nvSpPr>
@@ -6352,7 +6376,7 @@
       </p:sp>
       <p:sp>
         <p:nvSpPr>
-          <p:cNvPr id="62" name="TextBox 61"/>
+          <p:cNvPr id="63" name="TextBox 62"/>
           <p:cNvSpPr txBox="1"/>
           <p:nvPr/>
         </p:nvSpPr>

</xml_diff>

<commit_message>
Poster: Ann's 21 Oct edits and comments; notebook answering her C7-C9 questions
build_poster.py takes Ann's text edits from Ahmad_aaar_poster_2026_v2_AMD.pptx (new title,
intro bullet on SPARTAN sites vs Addis, figure references, Dillner & Takahama 2015 citation,
"QC checks", softer "Why IMPROVE?", key-term wording, Figure 4 caption, Figure 5 header,
conclusions), drops the 246-filter sentence, and refocuses next steps on why Dry and Belg
fail and on OC/EC selection. Map, explorer and season figures trimmed slightly to fit.

research/ftir_hips_chem/ann_followup_20261021.ipynb (built by
workflows/build_ann_followup_20261021_notebook.py): the same raw SPARTAN-like and
baseline-corrected calibrations on Addis and the 97 IMPROVE look-alikes, Figures 4b and 5b in
ug per filter, Addis vs look-alike spectra (raw, baselined, per ug EC) overall and by season,
and the season pooling question.

Co-Authored-By: Claude Opus 5.5 <noreply@anthropic.com>
</commit_message>
<xml_diff>
--- a/deliverables/aaar_poster_2026/aaar_poster_2026.pptx
+++ b/deliverables/aaar_poster_2026/aaar_poster_2026.pptx
@@ -3210,7 +3210,7 @@
                 </a:solidFill>
                 <a:latin typeface="Calibri"/>
               </a:rPr>
-              <a:t>Comparison of FTIR elemental carbon (EC) measurements in Addis Ababa, Ethiopia with rural U.S. IMPROVE EC measurements</a:t>
+              <a:t>Challenges of using rural U.S. IMPROVE FTIR elemental carbon (EC) measurements to calibrate FTIR EC in Addis Ababa, Ethiopia</a:t>
             </a:r>
           </a:p>
         </p:txBody>
@@ -3607,7 +3607,7 @@
         <p:spPr>
           <a:xfrm>
             <a:off x="1051560" y="7406640"/>
-            <a:ext cx="11978640" cy="5755640"/>
+            <a:ext cx="11978640" cy="6306820"/>
           </a:xfrm>
           <a:prstGeom prst="rect">
             <a:avLst/>
@@ -3668,7 +3668,7 @@
                 </a:solidFill>
                 <a:latin typeface="Calibri"/>
               </a:rPr>
-              <a:t> (Surface PARTiculate mAtter Network, www.spartan-network.org) samples particles onto filters in cities around the world, mostly in the Global South. It measures EC by </a:t>
+              <a:t> (Surface PARTiculate mAtter Network, www.spartan-network.org, Fig 1) samples particles onto filters in cities around the world, mostly in the Global South. It measures EC by </a:t>
             </a:r>
             <a:r>
               <a:rPr sz="2800" b="1" i="0">
@@ -3697,22 +3697,13 @@
               <a:buChar char="•"/>
             </a:pPr>
             <a:r>
-              <a:rPr sz="2800" b="1" i="0">
-                <a:solidFill>
-                  <a:srgbClr val="22252A"/>
-                </a:solidFill>
-                <a:latin typeface="Calibri"/>
-              </a:rPr>
-              <a:t>Addis Ababa</a:t>
-            </a:r>
-            <a:r>
               <a:rPr sz="2800" b="0" i="0">
                 <a:solidFill>
                   <a:srgbClr val="22252A"/>
                 </a:solidFill>
                 <a:latin typeface="Calibri"/>
               </a:rPr>
-              <a:t>, capital of Ethiopia (about 2,400 m elevation, about 5 million people), has some of the highest EC in SPARTAN. Households cook and heat with wood and charcoal.</a:t>
+              <a:t>FTIR EC compares well to absorption measurements (Fabs) at most SPARTAN sites, but not in Addis Ababa.</a:t>
             </a:r>
           </a:p>
           <a:p>
@@ -3723,12 +3714,38 @@
               <a:buChar char="•"/>
             </a:pPr>
             <a:r>
+              <a:rPr sz="2800" b="1" i="0">
+                <a:solidFill>
+                  <a:srgbClr val="22252A"/>
+                </a:solidFill>
+                <a:latin typeface="Calibri"/>
+              </a:rPr>
+              <a:t>Addis Ababa</a:t>
+            </a:r>
+            <a:r>
               <a:rPr sz="2800" b="0" i="0">
                 <a:solidFill>
                   <a:srgbClr val="22252A"/>
                 </a:solidFill>
                 <a:latin typeface="Calibri"/>
               </a:rPr>
+              <a:t>, capital of Ethiopia (about 2,400 m elevation, about 5 million people), has some of the highest EC in SPARTAN. Households cook and heat with wood and charcoal.</a:t>
+            </a:r>
+          </a:p>
+          <a:p>
+            <a:pPr algn="l" marL="384048" indent="-384048">
+              <a:spcAft>
+                <a:spcPts val="979"/>
+              </a:spcAft>
+              <a:buChar char="•"/>
+            </a:pPr>
+            <a:r>
+              <a:rPr sz="2800" b="0" i="0">
+                <a:solidFill>
+                  <a:srgbClr val="22252A"/>
+                </a:solidFill>
+                <a:latin typeface="Calibri"/>
+              </a:rPr>
               <a:t>We use 189 Addis filters (Dec 2022 to Sep 2024) across three seasons: </a:t>
             </a:r>
             <a:r>
@@ -3783,7 +3800,7 @@
                 </a:solidFill>
                 <a:latin typeface="Calibri"/>
               </a:rPr>
-              <a:t> long rains (Jun to Sep). All 246 Addis filters in the public SPARTAN release give the same result.</a:t>
+              <a:t> long rains (Jun to Sep).</a:t>
             </a:r>
           </a:p>
         </p:txBody>
@@ -3804,8 +3821,8 @@
         </p:blipFill>
         <p:spPr>
           <a:xfrm>
-            <a:off x="2240280" y="13162280"/>
-            <a:ext cx="9601200" cy="4467084"/>
+            <a:off x="2971800" y="13713460"/>
+            <a:ext cx="8138159" cy="3786386"/>
           </a:xfrm>
           <a:prstGeom prst="rect">
             <a:avLst/>
@@ -3820,7 +3837,7 @@
         </p:nvSpPr>
         <p:spPr>
           <a:xfrm>
-            <a:off x="1051560" y="17675084"/>
+            <a:off x="1051560" y="17545566"/>
             <a:ext cx="11978640" cy="896620"/>
           </a:xfrm>
           <a:prstGeom prst="rect">
@@ -3868,7 +3885,7 @@
         </p:nvSpPr>
         <p:spPr>
           <a:xfrm>
-            <a:off x="777240" y="18800304"/>
+            <a:off x="777240" y="18670786"/>
             <a:ext cx="12527280" cy="777240"/>
           </a:xfrm>
           <a:prstGeom prst="rect">
@@ -3921,8 +3938,8 @@
         </p:nvSpPr>
         <p:spPr>
           <a:xfrm>
-            <a:off x="1051560" y="19760424"/>
-            <a:ext cx="11978640" cy="4226560"/>
+            <a:off x="1051560" y="19630906"/>
+            <a:ext cx="11978640" cy="4653280"/>
           </a:xfrm>
           <a:prstGeom prst="rect">
             <a:avLst/>
@@ -3956,7 +3973,7 @@
                 </a:solidFill>
                 <a:latin typeface="Calibri"/>
               </a:rPr>
-              <a:t> (Fourier-transform infrared spectroscopy) passes infrared light through a Teflon filter and records how much is absorbed at each wavenumber. That curve is the filter's </a:t>
+              <a:t> (Fourier-transform infrared spectroscopy) passes infrared light through a Teflon filter and records absorption across the wavenumbers. That curve is the filter's </a:t>
             </a:r>
             <a:r>
               <a:rPr sz="2800" b="1" i="0">
@@ -4026,7 +4043,7 @@
                 </a:solidFill>
                 <a:latin typeface="Calibri"/>
               </a:rPr>
-              <a:t>: real IMPROVE filters on which the same air was collected on a Teflon filter (FTIR spectrum) and on a quartz filter (EC measured by </a:t>
+              <a:t> (Dillner and Takahama, 2015): IMPROVE filters on which the same air was collected on a Teflon filter (FTIR spectrum) and on a quartz filter (EC measured by </a:t>
             </a:r>
             <a:r>
               <a:rPr sz="2800" b="1" i="0">
@@ -4044,7 +4061,7 @@
                 </a:solidFill>
                 <a:latin typeface="Calibri"/>
               </a:rPr>
-              <a:t>, the reference method).</a:t>
+              <a:t>, the reference method) (Figs 1 and 2).</a:t>
             </a:r>
           </a:p>
         </p:txBody>
@@ -4057,7 +4074,7 @@
         </p:nvSpPr>
         <p:spPr>
           <a:xfrm>
-            <a:off x="1051560" y="24078424"/>
+            <a:off x="1051560" y="24375626"/>
             <a:ext cx="3337560" cy="3063240"/>
           </a:xfrm>
           <a:prstGeom prst="roundRect">
@@ -4150,7 +4167,7 @@
         </p:nvSpPr>
         <p:spPr>
           <a:xfrm>
-            <a:off x="4434840" y="24585916"/>
+            <a:off x="4434840" y="24883118"/>
             <a:ext cx="502920" cy="411480"/>
           </a:xfrm>
           <a:prstGeom prst="rightArrow">
@@ -4194,7 +4211,7 @@
         </p:nvSpPr>
         <p:spPr>
           <a:xfrm>
-            <a:off x="4434840" y="26231836"/>
+            <a:off x="4434840" y="26529038"/>
             <a:ext cx="502920" cy="411480"/>
           </a:xfrm>
           <a:prstGeom prst="rightArrow">
@@ -4238,7 +4255,7 @@
         </p:nvSpPr>
         <p:spPr>
           <a:xfrm>
-            <a:off x="4983479" y="24078424"/>
+            <a:off x="4983479" y="24375626"/>
             <a:ext cx="3154680" cy="1417320"/>
           </a:xfrm>
           <a:prstGeom prst="roundRect">
@@ -4316,7 +4333,7 @@
         </p:nvSpPr>
         <p:spPr>
           <a:xfrm>
-            <a:off x="4983479" y="25724344"/>
+            <a:off x="4983479" y="26021546"/>
             <a:ext cx="3154680" cy="1417320"/>
           </a:xfrm>
           <a:prstGeom prst="roundRect">
@@ -4394,7 +4411,7 @@
         </p:nvSpPr>
         <p:spPr>
           <a:xfrm>
-            <a:off x="8183879" y="24832804"/>
+            <a:off x="8183879" y="25130006"/>
             <a:ext cx="502920" cy="411480"/>
           </a:xfrm>
           <a:prstGeom prst="rightArrow">
@@ -4438,7 +4455,7 @@
         </p:nvSpPr>
         <p:spPr>
           <a:xfrm>
-            <a:off x="8183879" y="25975804"/>
+            <a:off x="8183879" y="26273006"/>
             <a:ext cx="502920" cy="411480"/>
           </a:xfrm>
           <a:prstGeom prst="rightArrow">
@@ -4482,7 +4499,7 @@
         </p:nvSpPr>
         <p:spPr>
           <a:xfrm>
-            <a:off x="8732519" y="24078424"/>
+            <a:off x="8732519" y="24375626"/>
             <a:ext cx="4297680" cy="3063240"/>
           </a:xfrm>
           <a:prstGeom prst="roundRect">
@@ -4575,7 +4592,7 @@
         </p:nvSpPr>
         <p:spPr>
           <a:xfrm>
-            <a:off x="10607039" y="27187384"/>
+            <a:off x="10607039" y="27484586"/>
             <a:ext cx="548640" cy="457200"/>
           </a:xfrm>
           <a:prstGeom prst="downArrow">
@@ -4619,7 +4636,7 @@
         </p:nvSpPr>
         <p:spPr>
           <a:xfrm>
-            <a:off x="1051560" y="27690304"/>
+            <a:off x="1051560" y="27987506"/>
             <a:ext cx="11978640" cy="1143000"/>
           </a:xfrm>
           <a:prstGeom prst="roundRect">
@@ -4681,7 +4698,7 @@
                 </a:solidFill>
                 <a:latin typeface="Calibri"/>
               </a:rPr>
-              <a:t> spectra (Addis Ababa): FTIR EC, checked against </a:t>
+              <a:t> spectra (Addis Ababa): FTIR EC, QC checks against </a:t>
             </a:r>
             <a:r>
               <a:rPr sz="2100" b="1" i="0">
@@ -4699,7 +4716,7 @@
                 </a:solidFill>
                 <a:latin typeface="Calibri"/>
               </a:rPr>
-              <a:t> light absorption (no TOR at Addis)</a:t>
+              <a:t> light absorption (Fig 4b; no TOR at Addis)</a:t>
             </a:r>
           </a:p>
         </p:txBody>
@@ -4712,7 +4729,7 @@
         </p:nvSpPr>
         <p:spPr>
           <a:xfrm>
-            <a:off x="1051560" y="28970464"/>
+            <a:off x="1051560" y="29267666"/>
             <a:ext cx="11978640" cy="546100"/>
           </a:xfrm>
           <a:prstGeom prst="rect">
@@ -4760,7 +4777,7 @@
         </p:nvSpPr>
         <p:spPr>
           <a:xfrm>
-            <a:off x="1051560" y="29699444"/>
+            <a:off x="1051560" y="29996646"/>
             <a:ext cx="11978640" cy="2290445"/>
           </a:xfrm>
           <a:prstGeom prst="rect">
@@ -4806,7 +4823,7 @@
         </p:nvSpPr>
         <p:spPr>
           <a:xfrm>
-            <a:off x="1188719" y="29772596"/>
+            <a:off x="1188719" y="30069798"/>
             <a:ext cx="11704319" cy="2153285"/>
           </a:xfrm>
           <a:prstGeom prst="rect">
@@ -4841,7 +4858,7 @@
                 </a:solidFill>
                 <a:latin typeface="Calibri"/>
               </a:rPr>
-              <a:t> Because it is the only data set that exists: no other library of matched Teflon (FTIR) and quartz (TOR) ambient filters exists anywhere, from Addis Ababa or any other city. CSN (the US urban network) filters are bigger and thicker and sample at a lower flow, so FTIR calibrations built on them predict less well.</a:t>
+              <a:t> Because it is the only data set that exists: no other large library of matched Teflon (FTIR) and quartz (TOR) ambient filters exists, and there are no quartz filters from Addis Ababa. CSN (the US urban network) filters are bigger and thicker and sample at a lower flow, so FTIR calibrations built on CSN filters predict less well.</a:t>
             </a:r>
           </a:p>
         </p:txBody>
@@ -4854,7 +4871,7 @@
         </p:nvSpPr>
         <p:spPr>
           <a:xfrm>
-            <a:off x="777240" y="32218489"/>
+            <a:off x="777240" y="32515691"/>
             <a:ext cx="12527280" cy="777240"/>
           </a:xfrm>
           <a:prstGeom prst="rect">
@@ -4907,8 +4924,8 @@
         </p:nvSpPr>
         <p:spPr>
           <a:xfrm>
-            <a:off x="1051560" y="33132889"/>
-            <a:ext cx="11978640" cy="7257288"/>
+            <a:off x="1051560" y="33430091"/>
+            <a:ext cx="11978640" cy="6516624"/>
           </a:xfrm>
           <a:prstGeom prst="rect">
             <a:avLst/>
@@ -4923,11 +4940,11 @@
           <a:p>
             <a:pPr algn="l">
               <a:spcAft>
-                <a:spcPts val="528"/>
+                <a:spcPts val="413"/>
               </a:spcAft>
             </a:pPr>
             <a:r>
-              <a:rPr sz="2400" b="1" i="0">
+              <a:rPr sz="2300" b="1" i="0">
                 <a:solidFill>
                   <a:srgbClr val="22252A"/>
                 </a:solidFill>
@@ -4936,7 +4953,7 @@
               <a:t>IMPROVE</a:t>
             </a:r>
             <a:r>
-              <a:rPr sz="2400" b="0" i="0">
+              <a:rPr sz="2300" b="0" i="0">
                 <a:solidFill>
                   <a:srgbClr val="22252A"/>
                 </a:solidFill>
@@ -4948,11 +4965,11 @@
           <a:p>
             <a:pPr algn="l">
               <a:spcAft>
-                <a:spcPts val="528"/>
+                <a:spcPts val="413"/>
               </a:spcAft>
             </a:pPr>
             <a:r>
-              <a:rPr sz="2400" b="1" i="0">
+              <a:rPr sz="2300" b="1" i="0">
                 <a:solidFill>
                   <a:srgbClr val="22252A"/>
                 </a:solidFill>
@@ -4961,23 +4978,23 @@
               <a:t>TOR</a:t>
             </a:r>
             <a:r>
-              <a:rPr sz="2400" b="0" i="0">
-                <a:solidFill>
-                  <a:srgbClr val="22252A"/>
-                </a:solidFill>
-                <a:latin typeface="Calibri"/>
-              </a:rPr>
-              <a:t>: thermal-optical reflectance. Heats a punch of a quartz filter and measures the carbon released; the standard reference for EC.</a:t>
+              <a:rPr sz="2300" b="0" i="0">
+                <a:solidFill>
+                  <a:srgbClr val="22252A"/>
+                </a:solidFill>
+                <a:latin typeface="Calibri"/>
+              </a:rPr>
+              <a:t>: thermal-optical reflectance. Heats a quartz filter and measures the carbon that evolves; the standard reference for EC.</a:t>
             </a:r>
           </a:p>
           <a:p>
             <a:pPr algn="l">
               <a:spcAft>
-                <a:spcPts val="528"/>
+                <a:spcPts val="413"/>
               </a:spcAft>
             </a:pPr>
             <a:r>
-              <a:rPr sz="2400" b="1" i="0">
+              <a:rPr sz="2300" b="1" i="0">
                 <a:solidFill>
                   <a:srgbClr val="22252A"/>
                 </a:solidFill>
@@ -4986,7 +5003,7 @@
               <a:t>HIPS</a:t>
             </a:r>
             <a:r>
-              <a:rPr sz="2400" b="0" i="0">
+              <a:rPr sz="2300" b="0" i="0">
                 <a:solidFill>
                   <a:srgbClr val="22252A"/>
                 </a:solidFill>
@@ -4995,7 +5012,7 @@
               <a:t>: hybrid integrating plate/sphere. Measures how much red light (633 nm) a Teflon filter absorbs, called </a:t>
             </a:r>
             <a:r>
-              <a:rPr sz="2400" b="1" i="0">
+              <a:rPr sz="2300" b="1" i="0">
                 <a:solidFill>
                   <a:srgbClr val="22252A"/>
                 </a:solidFill>
@@ -5004,7 +5021,7 @@
               <a:t>Fabs</a:t>
             </a:r>
             <a:r>
-              <a:rPr sz="2400" b="0" i="0">
+              <a:rPr sz="2300" b="0" i="0">
                 <a:solidFill>
                   <a:srgbClr val="22252A"/>
                 </a:solidFill>
@@ -5016,11 +5033,11 @@
           <a:p>
             <a:pPr algn="l">
               <a:spcAft>
-                <a:spcPts val="528"/>
+                <a:spcPts val="413"/>
               </a:spcAft>
             </a:pPr>
             <a:r>
-              <a:rPr sz="2400" b="1" i="0">
+              <a:rPr sz="2300" b="1" i="0">
                 <a:solidFill>
                   <a:srgbClr val="22252A"/>
                 </a:solidFill>
@@ -5029,23 +5046,23 @@
               <a:t>MAC</a:t>
             </a:r>
             <a:r>
-              <a:rPr sz="2400" b="0" i="0">
-                <a:solidFill>
-                  <a:srgbClr val="22252A"/>
-                </a:solidFill>
-                <a:latin typeface="Calibri"/>
-              </a:rPr>
-              <a:t>: mass absorption cross-section, the light absorbed per gram of EC (m²/g). EC = Fabs / MAC. We use MAC = 10 m²/g, a common default; the true value varies with sources. Changing MAC changes the slope in Figure 4, not the intercept, so MAC alone cannot fix Addis.</a:t>
+              <a:rPr sz="2300" b="0" i="0">
+                <a:solidFill>
+                  <a:srgbClr val="22252A"/>
+                </a:solidFill>
+                <a:latin typeface="Calibri"/>
+              </a:rPr>
+              <a:t>: mass absorption cross-section, the light absorbed per gram of EC (m²/g). Fabs / MAC is a good estimate of EC. We use MAC = 10 m²/g, a common default; the true value varies with sources. Changing MAC changes the slope in Figure 4, not the intercept, so MAC alone cannot fix Addis' poor intercept.</a:t>
             </a:r>
           </a:p>
           <a:p>
             <a:pPr algn="l">
               <a:spcAft>
-                <a:spcPts val="528"/>
+                <a:spcPts val="413"/>
               </a:spcAft>
             </a:pPr>
             <a:r>
-              <a:rPr sz="2400" b="1" i="0">
+              <a:rPr sz="2300" b="1" i="0">
                 <a:solidFill>
                   <a:srgbClr val="22252A"/>
                 </a:solidFill>
@@ -5054,23 +5071,23 @@
               <a:t>Calibration set</a:t>
             </a:r>
             <a:r>
-              <a:rPr sz="2400" b="0" i="0">
-                <a:solidFill>
-                  <a:srgbClr val="22252A"/>
-                </a:solidFill>
-                <a:latin typeface="Calibri"/>
-              </a:rPr>
-              <a:t>: the IMPROVE filters (with TOR EC) that one calibration is built from.</a:t>
+              <a:rPr sz="2300" b="0" i="0">
+                <a:solidFill>
+                  <a:srgbClr val="22252A"/>
+                </a:solidFill>
+                <a:latin typeface="Calibri"/>
+              </a:rPr>
+              <a:t>: the IMPROVE filters (with TOR EC) that a calibration is built from.</a:t>
             </a:r>
           </a:p>
           <a:p>
             <a:pPr algn="l">
               <a:spcAft>
-                <a:spcPts val="528"/>
+                <a:spcPts val="413"/>
               </a:spcAft>
             </a:pPr>
             <a:r>
-              <a:rPr sz="2400" b="1" i="0">
+              <a:rPr sz="2300" b="1" i="0">
                 <a:solidFill>
                   <a:srgbClr val="22252A"/>
                 </a:solidFill>
@@ -5079,7 +5096,7 @@
               <a:t>PLS</a:t>
             </a:r>
             <a:r>
-              <a:rPr sz="2400" b="0" i="0">
+              <a:rPr sz="2300" b="0" i="0">
                 <a:solidFill>
                   <a:srgbClr val="22252A"/>
                 </a:solidFill>
@@ -5091,11 +5108,11 @@
           <a:p>
             <a:pPr algn="l">
               <a:spcAft>
-                <a:spcPts val="528"/>
+                <a:spcPts val="413"/>
               </a:spcAft>
             </a:pPr>
             <a:r>
-              <a:rPr sz="2400" b="1" i="0">
+              <a:rPr sz="2300" b="1" i="0">
                 <a:solidFill>
                   <a:srgbClr val="22252A"/>
                 </a:solidFill>
@@ -5104,7 +5121,7 @@
               <a:t>Baseline correction of the spectra</a:t>
             </a:r>
             <a:r>
-              <a:rPr sz="2400" b="0" i="0">
+              <a:rPr sz="2300" b="0" i="0">
                 <a:solidFill>
                   <a:srgbClr val="22252A"/>
                 </a:solidFill>
@@ -5116,11 +5133,11 @@
           <a:p>
             <a:pPr algn="l">
               <a:spcAft>
-                <a:spcPts val="528"/>
+                <a:spcPts val="413"/>
               </a:spcAft>
             </a:pPr>
             <a:r>
-              <a:rPr sz="2400" b="1" i="0">
+              <a:rPr sz="2300" b="1" i="0">
                 <a:solidFill>
                   <a:srgbClr val="22252A"/>
                 </a:solidFill>
@@ -5129,7 +5146,7 @@
               <a:t>Deming regression</a:t>
             </a:r>
             <a:r>
-              <a:rPr sz="2400" b="0" i="0">
+              <a:rPr sz="2300" b="0" i="0">
                 <a:solidFill>
                   <a:srgbClr val="22252A"/>
                 </a:solidFill>
@@ -5469,7 +5486,7 @@
                 </a:solidFill>
                 <a:latin typeface="Calibri"/>
               </a:rPr>
-              <a:t> FTIR against HIPS EC. The other SPARTAN sites together are predicted reasonably (grey line), and Addis sits inside that cloud, but Addis alone is well correlated with the wrong slope and intercept (2.3x -6.1). Every season is off (slopes 1.4 to 2.2).</a:t>
+              <a:t> FTIR against HIPS EC. The other SPARTAN sites together are predicted reasonably (grey data points and grey line); Addis alone is well correlated with the wrong slope and intercept (2.3x -6.1). Every season is off (slopes 1.4 to 2.2).</a:t>
             </a:r>
           </a:p>
         </p:txBody>
@@ -5522,7 +5539,7 @@
                 </a:solidFill>
                 <a:latin typeface="Calibri"/>
               </a:rPr>
-              <a:t>IMPROVE filters that look like Addis fail too</a:t>
+              <a:t>IMPROVE spectra that look like Addis spectra fail too</a:t>
             </a:r>
           </a:p>
         </p:txBody>
@@ -5651,7 +5668,7 @@
                 </a:solidFill>
                 <a:latin typeface="Calibri"/>
               </a:rPr>
-              <a:t> Grey: all IMPROVE filters; red: the 97 most like Addis. TOR and HIPS agree on them, but the same FTIR calibration predicts them poorly, at ordinary IMPROVE concentrations. Same calibration; only the samples changed.</a:t>
+              <a:t> Grey: all IMPROVE filters; red: the 97 most like Addis. TOR and HIPS agree on them, but the same FTIR calibration predicts them poorly, at IMPROVE concentrations. Same calibration; only the samples changed.</a:t>
             </a:r>
           </a:p>
         </p:txBody>
@@ -6019,7 +6036,7 @@
         <p:spPr>
           <a:xfrm>
             <a:off x="27203400" y="16353163"/>
-            <a:ext cx="11978640" cy="5398775"/>
+            <a:ext cx="11978640" cy="5080394"/>
           </a:xfrm>
           <a:prstGeom prst="rect">
             <a:avLst/>
@@ -6034,7 +6051,7 @@
         </p:nvSpPr>
         <p:spPr>
           <a:xfrm>
-            <a:off x="27203400" y="21797658"/>
+            <a:off x="27203400" y="21479278"/>
             <a:ext cx="11978640" cy="1597659"/>
           </a:xfrm>
           <a:prstGeom prst="rect">
@@ -6082,7 +6099,7 @@
         </p:nvSpPr>
         <p:spPr>
           <a:xfrm>
-            <a:off x="27203400" y="23578198"/>
+            <a:off x="27203400" y="23259818"/>
             <a:ext cx="11978640" cy="1045209"/>
           </a:xfrm>
           <a:prstGeom prst="rect">
@@ -6138,8 +6155,8 @@
         </p:blipFill>
         <p:spPr>
           <a:xfrm>
-            <a:off x="27203400" y="24669128"/>
-            <a:ext cx="11978640" cy="5192898"/>
+            <a:off x="27203400" y="24350748"/>
+            <a:ext cx="11978640" cy="4843156"/>
           </a:xfrm>
           <a:prstGeom prst="rect">
             <a:avLst/>
@@ -6154,7 +6171,7 @@
         </p:nvSpPr>
         <p:spPr>
           <a:xfrm>
-            <a:off x="27203400" y="29907747"/>
+            <a:off x="27203400" y="29239625"/>
             <a:ext cx="11978640" cy="896620"/>
           </a:xfrm>
           <a:prstGeom prst="rect">
@@ -6202,7 +6219,7 @@
         </p:nvSpPr>
         <p:spPr>
           <a:xfrm>
-            <a:off x="26929080" y="31032967"/>
+            <a:off x="26929080" y="30364845"/>
             <a:ext cx="12527280" cy="777240"/>
           </a:xfrm>
           <a:prstGeom prst="rect">
@@ -6255,8 +6272,8 @@
         </p:nvSpPr>
         <p:spPr>
           <a:xfrm>
-            <a:off x="27203400" y="31993087"/>
-            <a:ext cx="11978640" cy="3383279"/>
+            <a:off x="27203400" y="31324965"/>
+            <a:ext cx="11978640" cy="4114800"/>
           </a:xfrm>
           <a:prstGeom prst="rect">
             <a:avLst/>
@@ -6299,7 +6316,7 @@
                 </a:solidFill>
                 <a:latin typeface="Calibri"/>
               </a:rPr>
-              <a:t>Concentration is not the whole story: IMPROVE filters with Addis-like spectra are poorly predicted at ordinary IMPROVE levels. Addis burns different fuels (wood, charcoal) from rural US sites, so its EC may differ in composition.</a:t>
+              <a:t>Concentration is not the whole story: IMPROVE filters with Addis-like spectra are poorly predicted at IMPROVE concentrations. Addis burns different fuels (wood, charcoal) from rural US sites, so its EC may differ in composition.</a:t>
             </a:r>
           </a:p>
           <a:p>
@@ -6316,7 +6333,7 @@
                 </a:solidFill>
                 <a:latin typeface="Calibri"/>
               </a:rPr>
-              <a:t>Next: choose calibration filters by EC-to-PM2.5 ratio; check TOR on the heaviest smoke-affected IMPROVE filters; longer term, collocated Teflon and quartz filters in Addis Ababa.</a:t>
+              <a:t>Next: find out why the Dry and Belg seasons are poorly predicted (compare IMPROVE and Addis spectra by season); try choosing calibration filters by OC/EC ratio; check TOR on the heaviest smoke-affected IMPROVE filters; longer term, collect collocated Teflon and quartz filters in Addis Ababa, at least some to check calibrations.</a:t>
             </a:r>
           </a:p>
         </p:txBody>
@@ -6329,7 +6346,7 @@
         </p:nvSpPr>
         <p:spPr>
           <a:xfrm>
-            <a:off x="26929080" y="35559247"/>
+            <a:off x="26929080" y="35622645"/>
             <a:ext cx="12527280" cy="777240"/>
           </a:xfrm>
           <a:prstGeom prst="rect">
@@ -6382,8 +6399,8 @@
         </p:nvSpPr>
         <p:spPr>
           <a:xfrm>
-            <a:off x="27203400" y="36473647"/>
-            <a:ext cx="11978640" cy="3990974"/>
+            <a:off x="27203400" y="36537045"/>
+            <a:ext cx="11978640" cy="3915409"/>
           </a:xfrm>
           <a:prstGeom prst="rect">
             <a:avLst/>
@@ -6398,7 +6415,7 @@
           <a:p>
             <a:pPr algn="l">
               <a:spcAft>
-                <a:spcPts val="254"/>
+                <a:spcPts val="170"/>
               </a:spcAft>
             </a:pPr>
             <a:r>
@@ -6432,7 +6449,7 @@
           <a:p>
             <a:pPr algn="l">
               <a:spcAft>
-                <a:spcPts val="254"/>
+                <a:spcPts val="170"/>
               </a:spcAft>
             </a:pPr>
             <a:r>
@@ -6466,7 +6483,7 @@
           <a:p>
             <a:pPr algn="l">
               <a:spcAft>
-                <a:spcPts val="254"/>
+                <a:spcPts val="170"/>
               </a:spcAft>
             </a:pPr>
             <a:r>
@@ -6500,7 +6517,7 @@
           <a:p>
             <a:pPr algn="l">
               <a:spcAft>
-                <a:spcPts val="254"/>
+                <a:spcPts val="170"/>
               </a:spcAft>
             </a:pPr>
             <a:r>
@@ -6534,7 +6551,7 @@
           <a:p>
             <a:pPr algn="l">
               <a:spcAft>
-                <a:spcPts val="254"/>
+                <a:spcPts val="170"/>
               </a:spcAft>
             </a:pPr>
             <a:r>
@@ -6568,7 +6585,7 @@
           <a:p>
             <a:pPr algn="l">
               <a:spcAft>
-                <a:spcPts val="254"/>
+                <a:spcPts val="170"/>
               </a:spcAft>
             </a:pPr>
             <a:r>
@@ -6602,7 +6619,7 @@
           <a:p>
             <a:pPr algn="l">
               <a:spcAft>
-                <a:spcPts val="254"/>
+                <a:spcPts val="170"/>
               </a:spcAft>
             </a:pPr>
             <a:r>

</xml_diff>

<commit_message>
Poster: name Figure 5's calibration; conclusions state the per-EC organic deficit
Figure 5's caption now says it uses the baseline-corrected calibration (as in Figure 4,
IMPROVE, and Figure 7, right), since Figures 4b and 5b use different calibrations. The second
conclusion replaces the fuels speculation with the result from ann_followup_20261021.ipynb:
per ug of EC, Addis spectra carry about a tenth of the organic signal of their IMPROVE
look-alikes (least in Dry, most in Kiremt). Histogram, explorer and season figures trimmed
slightly to fit.

Co-Authored-By: Claude Opus 5.5 <noreply@anthropic.com>
</commit_message>
<xml_diff>
--- a/deliverables/aaar_poster_2026/aaar_poster_2026.pptx
+++ b/deliverables/aaar_poster_2026/aaar_poster_2026.pptx
@@ -5634,7 +5634,7 @@
         <p:spPr>
           <a:xfrm>
             <a:off x="14127480" y="31303485"/>
-            <a:ext cx="11978640" cy="1247139"/>
+            <a:ext cx="11978640" cy="1597659"/>
           </a:xfrm>
           <a:prstGeom prst="rect">
             <a:avLst/>
@@ -5668,7 +5668,7 @@
                 </a:solidFill>
                 <a:latin typeface="Calibri"/>
               </a:rPr>
-              <a:t> Grey: all IMPROVE filters; red: the 97 most like Addis. TOR and HIPS agree on them, but the same FTIR calibration predicts them poorly, at IMPROVE concentrations. Same calibration; only the samples changed.</a:t>
+              <a:t> Grey: all IMPROVE filters; red: the 97 most like Addis. TOR and HIPS agree on them, but the baseline-corrected FTIR calibration (as in Figure 4, IMPROVE, and Figure 7, right) predicts them poorly, at IMPROVE concentrations. Same calibration; only the samples changed.</a:t>
             </a:r>
           </a:p>
         </p:txBody>
@@ -5681,7 +5681,7 @@
         </p:nvSpPr>
         <p:spPr>
           <a:xfrm>
-            <a:off x="13853159" y="32779225"/>
+            <a:off x="13853159" y="33129745"/>
             <a:ext cx="12527280" cy="777240"/>
           </a:xfrm>
           <a:prstGeom prst="rect">
@@ -5742,8 +5742,8 @@
         </p:blipFill>
         <p:spPr>
           <a:xfrm>
-            <a:off x="14493240" y="33739345"/>
-            <a:ext cx="11247119" cy="4927726"/>
+            <a:off x="14493240" y="34089865"/>
+            <a:ext cx="11247119" cy="4726416"/>
           </a:xfrm>
           <a:prstGeom prst="rect">
             <a:avLst/>
@@ -5758,7 +5758,7 @@
         </p:nvSpPr>
         <p:spPr>
           <a:xfrm>
-            <a:off x="14127480" y="38712792"/>
+            <a:off x="14127480" y="38862001"/>
             <a:ext cx="11978640" cy="1247139"/>
           </a:xfrm>
           <a:prstGeom prst="rect">
@@ -6036,7 +6036,7 @@
         <p:spPr>
           <a:xfrm>
             <a:off x="27203400" y="16353163"/>
-            <a:ext cx="11978640" cy="5080394"/>
+            <a:ext cx="11978640" cy="4686698"/>
           </a:xfrm>
           <a:prstGeom prst="rect">
             <a:avLst/>
@@ -6051,7 +6051,7 @@
         </p:nvSpPr>
         <p:spPr>
           <a:xfrm>
-            <a:off x="27203400" y="21479278"/>
+            <a:off x="27203400" y="21085582"/>
             <a:ext cx="11978640" cy="1597659"/>
           </a:xfrm>
           <a:prstGeom prst="rect">
@@ -6099,7 +6099,7 @@
         </p:nvSpPr>
         <p:spPr>
           <a:xfrm>
-            <a:off x="27203400" y="23259818"/>
+            <a:off x="27203400" y="22866122"/>
             <a:ext cx="11978640" cy="1045209"/>
           </a:xfrm>
           <a:prstGeom prst="rect">
@@ -6155,8 +6155,8 @@
         </p:blipFill>
         <p:spPr>
           <a:xfrm>
-            <a:off x="27203400" y="24350748"/>
-            <a:ext cx="11978640" cy="4843156"/>
+            <a:off x="27203400" y="23957052"/>
+            <a:ext cx="11978640" cy="4668286"/>
           </a:xfrm>
           <a:prstGeom prst="rect">
             <a:avLst/>
@@ -6171,7 +6171,7 @@
         </p:nvSpPr>
         <p:spPr>
           <a:xfrm>
-            <a:off x="27203400" y="29239625"/>
+            <a:off x="27203400" y="28671058"/>
             <a:ext cx="11978640" cy="896620"/>
           </a:xfrm>
           <a:prstGeom prst="rect">
@@ -6219,7 +6219,7 @@
         </p:nvSpPr>
         <p:spPr>
           <a:xfrm>
-            <a:off x="26929080" y="30364845"/>
+            <a:off x="26929080" y="29704838"/>
             <a:ext cx="12527280" cy="777240"/>
           </a:xfrm>
           <a:prstGeom prst="rect">
@@ -6272,8 +6272,8 @@
         </p:nvSpPr>
         <p:spPr>
           <a:xfrm>
-            <a:off x="27203400" y="31324965"/>
-            <a:ext cx="11978640" cy="4114800"/>
+            <a:off x="27203400" y="30664958"/>
+            <a:ext cx="11978640" cy="4846320"/>
           </a:xfrm>
           <a:prstGeom prst="rect">
             <a:avLst/>
@@ -6316,7 +6316,7 @@
                 </a:solidFill>
                 <a:latin typeface="Calibri"/>
               </a:rPr>
-              <a:t>Concentration is not the whole story: IMPROVE filters with Addis-like spectra are poorly predicted at IMPROVE concentrations. Addis burns different fuels (wood, charcoal) from rural US sites, so its EC may differ in composition.</a:t>
+              <a:t>Concentration is not the whole story: IMPROVE filters with Addis-like spectra are poorly predicted at IMPROVE concentrations. Per µg of EC, Addis spectra carry about a tenth of the organic signal of those look-alikes (least in Dry, most in Kiremt); calibrations trained on IMPROVE partly read EC through organic bands, so they read Addis low.</a:t>
             </a:r>
           </a:p>
           <a:p>
@@ -6346,7 +6346,7 @@
         </p:nvSpPr>
         <p:spPr>
           <a:xfrm>
-            <a:off x="26929080" y="35622645"/>
+            <a:off x="26929080" y="35602718"/>
             <a:ext cx="12527280" cy="777240"/>
           </a:xfrm>
           <a:prstGeom prst="rect">
@@ -6399,7 +6399,7 @@
         </p:nvSpPr>
         <p:spPr>
           <a:xfrm>
-            <a:off x="27203400" y="36537045"/>
+            <a:off x="27203400" y="36517118"/>
             <a:ext cx="11978640" cy="3915409"/>
           </a:xfrm>
           <a:prstGeom prst="rect">

</xml_diff>

<commit_message>
Poster: MATTER lab logo on the left, between UNBC and UC Davis AQRC
The three left logos are scaled to 8.4 in (MATTER 1.75 in tall) and spread evenly over the
header. matter.png is rendered from the lab's SVG at 2,400 px and trimmed.

Co-Authored-By: Claude Opus 5.5 <noreply@anthropic.com>
</commit_message>
<xml_diff>
--- a/deliverables/aaar_poster_2026/aaar_poster_2026.pptx
+++ b/deliverables/aaar_poster_2026/aaar_poster_2026.pptx
@@ -3309,8 +3309,8 @@
         </p:blipFill>
         <p:spPr>
           <a:xfrm>
-            <a:off x="1371600" y="1097280"/>
-            <a:ext cx="8595360" cy="1481631"/>
+            <a:off x="1371600" y="777240"/>
+            <a:ext cx="7680960" cy="1324010"/>
           </a:xfrm>
           <a:prstGeom prst="rect">
             <a:avLst/>
@@ -3319,7 +3319,7 @@
       </p:pic>
       <p:pic>
         <p:nvPicPr>
-          <p:cNvPr id="8" name="Picture 7" descr="ucdavis_aqrc.png"/>
+          <p:cNvPr id="8" name="Picture 7" descr="matter.png"/>
           <p:cNvPicPr>
             <a:picLocks noChangeAspect="1"/>
           </p:cNvPicPr>
@@ -3333,8 +3333,8 @@
         </p:blipFill>
         <p:spPr>
           <a:xfrm>
-            <a:off x="1371600" y="3291840"/>
-            <a:ext cx="8595360" cy="1460749"/>
+            <a:off x="1371600" y="2455349"/>
+            <a:ext cx="4133993" cy="1600200"/>
           </a:xfrm>
           <a:prstGeom prst="rect">
             <a:avLst/>
@@ -3343,7 +3343,7 @@
       </p:pic>
       <p:pic>
         <p:nvPicPr>
-          <p:cNvPr id="9" name="Picture 8" descr="nasa_jpl.png"/>
+          <p:cNvPr id="9" name="Picture 8" descr="ucdavis_aqrc.png"/>
           <p:cNvPicPr>
             <a:picLocks noChangeAspect="1"/>
           </p:cNvPicPr>
@@ -3357,8 +3357,8 @@
         </p:blipFill>
         <p:spPr>
           <a:xfrm>
-            <a:off x="30175200" y="1490472"/>
-            <a:ext cx="6035040" cy="1136644"/>
+            <a:off x="1371600" y="4409649"/>
+            <a:ext cx="7680960" cy="1305350"/>
           </a:xfrm>
           <a:prstGeom prst="rect">
             <a:avLst/>
@@ -3367,7 +3367,7 @@
       </p:pic>
       <p:pic>
         <p:nvPicPr>
-          <p:cNvPr id="10" name="Picture 9" descr="maia.png"/>
+          <p:cNvPr id="10" name="Picture 9" descr="nasa_jpl.png"/>
           <p:cNvPicPr>
             <a:picLocks noChangeAspect="1"/>
           </p:cNvPicPr>
@@ -3381,8 +3381,8 @@
         </p:blipFill>
         <p:spPr>
           <a:xfrm>
-            <a:off x="36530280" y="731520"/>
-            <a:ext cx="2651760" cy="2651760"/>
+            <a:off x="30175200" y="1490472"/>
+            <a:ext cx="6035040" cy="1136644"/>
           </a:xfrm>
           <a:prstGeom prst="rect">
             <a:avLst/>
@@ -3391,7 +3391,7 @@
       </p:pic>
       <p:pic>
         <p:nvPicPr>
-          <p:cNvPr id="11" name="Picture 10" descr="spartan_cyan.png"/>
+          <p:cNvPr id="11" name="Picture 10" descr="maia.png"/>
           <p:cNvPicPr>
             <a:picLocks noChangeAspect="1"/>
           </p:cNvPicPr>
@@ -3405,409 +3405,17 @@
         </p:blipFill>
         <p:spPr>
           <a:xfrm>
-            <a:off x="31272480" y="3611880"/>
-            <a:ext cx="6766560" cy="1583119"/>
+            <a:off x="36530280" y="731520"/>
+            <a:ext cx="2651760" cy="2651760"/>
           </a:xfrm>
           <a:prstGeom prst="rect">
             <a:avLst/>
           </a:prstGeom>
         </p:spPr>
       </p:pic>
-      <p:sp>
-        <p:nvSpPr>
-          <p:cNvPr id="12" name="Rectangle 11"/>
-          <p:cNvSpPr/>
-          <p:nvPr/>
-        </p:nvSpPr>
-        <p:spPr>
-          <a:xfrm>
-            <a:off x="777240" y="6446520"/>
-            <a:ext cx="12527280" cy="34061400"/>
-          </a:xfrm>
-          <a:prstGeom prst="rect">
-            <a:avLst/>
-          </a:prstGeom>
-          <a:solidFill>
-            <a:srgbClr val="FFFFFF"/>
-          </a:solidFill>
-          <a:ln>
-            <a:noFill/>
-          </a:ln>
-          <a:effectLst/>
-        </p:spPr>
-        <p:style>
-          <a:lnRef idx="1">
-            <a:schemeClr val="accent1"/>
-          </a:lnRef>
-          <a:fillRef idx="3">
-            <a:schemeClr val="accent1"/>
-          </a:fillRef>
-          <a:effectRef idx="2">
-            <a:schemeClr val="accent1"/>
-          </a:effectRef>
-          <a:fontRef idx="minor">
-            <a:schemeClr val="lt1"/>
-          </a:fontRef>
-        </p:style>
-        <p:txBody>
-          <a:bodyPr rtlCol="0" anchor="ctr"/>
-          <a:lstStyle/>
-          <a:p>
-            <a:pPr algn="ctr"/>
-          </a:p>
-        </p:txBody>
-      </p:sp>
-      <p:sp>
-        <p:nvSpPr>
-          <p:cNvPr id="13" name="Rectangle 12"/>
-          <p:cNvSpPr/>
-          <p:nvPr/>
-        </p:nvSpPr>
-        <p:spPr>
-          <a:xfrm>
-            <a:off x="13853159" y="6446520"/>
-            <a:ext cx="12527280" cy="34061400"/>
-          </a:xfrm>
-          <a:prstGeom prst="rect">
-            <a:avLst/>
-          </a:prstGeom>
-          <a:solidFill>
-            <a:srgbClr val="FFFFFF"/>
-          </a:solidFill>
-          <a:ln>
-            <a:noFill/>
-          </a:ln>
-          <a:effectLst/>
-        </p:spPr>
-        <p:style>
-          <a:lnRef idx="1">
-            <a:schemeClr val="accent1"/>
-          </a:lnRef>
-          <a:fillRef idx="3">
-            <a:schemeClr val="accent1"/>
-          </a:fillRef>
-          <a:effectRef idx="2">
-            <a:schemeClr val="accent1"/>
-          </a:effectRef>
-          <a:fontRef idx="minor">
-            <a:schemeClr val="lt1"/>
-          </a:fontRef>
-        </p:style>
-        <p:txBody>
-          <a:bodyPr rtlCol="0" anchor="ctr"/>
-          <a:lstStyle/>
-          <a:p>
-            <a:pPr algn="ctr"/>
-          </a:p>
-        </p:txBody>
-      </p:sp>
-      <p:sp>
-        <p:nvSpPr>
-          <p:cNvPr id="14" name="Rectangle 13"/>
-          <p:cNvSpPr/>
-          <p:nvPr/>
-        </p:nvSpPr>
-        <p:spPr>
-          <a:xfrm>
-            <a:off x="26929080" y="6446520"/>
-            <a:ext cx="12527280" cy="34061400"/>
-          </a:xfrm>
-          <a:prstGeom prst="rect">
-            <a:avLst/>
-          </a:prstGeom>
-          <a:solidFill>
-            <a:srgbClr val="FFFFFF"/>
-          </a:solidFill>
-          <a:ln>
-            <a:noFill/>
-          </a:ln>
-          <a:effectLst/>
-        </p:spPr>
-        <p:style>
-          <a:lnRef idx="1">
-            <a:schemeClr val="accent1"/>
-          </a:lnRef>
-          <a:fillRef idx="3">
-            <a:schemeClr val="accent1"/>
-          </a:fillRef>
-          <a:effectRef idx="2">
-            <a:schemeClr val="accent1"/>
-          </a:effectRef>
-          <a:fontRef idx="minor">
-            <a:schemeClr val="lt1"/>
-          </a:fontRef>
-        </p:style>
-        <p:txBody>
-          <a:bodyPr rtlCol="0" anchor="ctr"/>
-          <a:lstStyle/>
-          <a:p>
-            <a:pPr algn="ctr"/>
-          </a:p>
-        </p:txBody>
-      </p:sp>
-      <p:sp>
-        <p:nvSpPr>
-          <p:cNvPr id="15" name="Rectangle 14"/>
-          <p:cNvSpPr/>
-          <p:nvPr/>
-        </p:nvSpPr>
-        <p:spPr>
-          <a:xfrm>
-            <a:off x="777240" y="6446520"/>
-            <a:ext cx="12527280" cy="777240"/>
-          </a:xfrm>
-          <a:prstGeom prst="rect">
-            <a:avLst/>
-          </a:prstGeom>
-          <a:solidFill>
-            <a:srgbClr val="1B365D"/>
-          </a:solidFill>
-          <a:ln>
-            <a:noFill/>
-          </a:ln>
-          <a:effectLst/>
-        </p:spPr>
-        <p:style>
-          <a:lnRef idx="1">
-            <a:schemeClr val="accent1"/>
-          </a:lnRef>
-          <a:fillRef idx="3">
-            <a:schemeClr val="accent1"/>
-          </a:fillRef>
-          <a:effectRef idx="2">
-            <a:schemeClr val="accent1"/>
-          </a:effectRef>
-          <a:fontRef idx="minor">
-            <a:schemeClr val="lt1"/>
-          </a:fontRef>
-        </p:style>
-        <p:txBody>
-          <a:bodyPr rtlCol="0" anchor="ctr" lIns="182880"/>
-          <a:lstStyle/>
-          <a:p>
-            <a:pPr algn="ctr"/>
-            <a:r>
-              <a:rPr sz="3800" b="1" i="0">
-                <a:solidFill>
-                  <a:srgbClr val="FFFFFF"/>
-                </a:solidFill>
-                <a:latin typeface="Calibri"/>
-              </a:rPr>
-              <a:t>Why elemental carbon in Addis Ababa?</a:t>
-            </a:r>
-          </a:p>
-        </p:txBody>
-      </p:sp>
-      <p:sp>
-        <p:nvSpPr>
-          <p:cNvPr id="16" name="TextBox 15"/>
-          <p:cNvSpPr txBox="1"/>
-          <p:nvPr/>
-        </p:nvSpPr>
-        <p:spPr>
-          <a:xfrm>
-            <a:off x="1051560" y="7406640"/>
-            <a:ext cx="11978640" cy="6306820"/>
-          </a:xfrm>
-          <a:prstGeom prst="rect">
-            <a:avLst/>
-          </a:prstGeom>
-          <a:noFill/>
-        </p:spPr>
-        <p:txBody>
-          <a:bodyPr wrap="square" tIns="27432" bIns="27432">
-            <a:spAutoFit/>
-          </a:bodyPr>
-          <a:lstStyle/>
-          <a:p>
-            <a:pPr algn="l" marL="384048" indent="-384048">
-              <a:spcAft>
-                <a:spcPts val="979"/>
-              </a:spcAft>
-              <a:buChar char="•"/>
-            </a:pPr>
-            <a:r>
-              <a:rPr sz="2800" b="1" i="0">
-                <a:solidFill>
-                  <a:srgbClr val="22252A"/>
-                </a:solidFill>
-                <a:latin typeface="Calibri"/>
-              </a:rPr>
-              <a:t>Elemental carbon (EC)</a:t>
-            </a:r>
-            <a:r>
-              <a:rPr sz="2800" b="0" i="0">
-                <a:solidFill>
-                  <a:srgbClr val="22252A"/>
-                </a:solidFill>
-                <a:latin typeface="Calibri"/>
-              </a:rPr>
-              <a:t> is the black, soot-like carbon from burning. It warms the climate and harms health.</a:t>
-            </a:r>
-          </a:p>
-          <a:p>
-            <a:pPr algn="l" marL="384048" indent="-384048">
-              <a:spcAft>
-                <a:spcPts val="979"/>
-              </a:spcAft>
-              <a:buChar char="•"/>
-            </a:pPr>
-            <a:r>
-              <a:rPr sz="2800" b="1" i="0">
-                <a:solidFill>
-                  <a:srgbClr val="22252A"/>
-                </a:solidFill>
-                <a:latin typeface="Calibri"/>
-              </a:rPr>
-              <a:t>SPARTAN</a:t>
-            </a:r>
-            <a:r>
-              <a:rPr sz="2800" b="0" i="0">
-                <a:solidFill>
-                  <a:srgbClr val="22252A"/>
-                </a:solidFill>
-                <a:latin typeface="Calibri"/>
-              </a:rPr>
-              <a:t> (Surface PARTiculate mAtter Network, www.spartan-network.org, Fig 1) samples particles onto filters in cities around the world, mostly in the Global South. It measures EC by </a:t>
-            </a:r>
-            <a:r>
-              <a:rPr sz="2800" b="1" i="0">
-                <a:solidFill>
-                  <a:srgbClr val="22252A"/>
-                </a:solidFill>
-                <a:latin typeface="Calibri"/>
-              </a:rPr>
-              <a:t>FTIR</a:t>
-            </a:r>
-            <a:r>
-              <a:rPr sz="2800" b="0" i="0">
-                <a:solidFill>
-                  <a:srgbClr val="22252A"/>
-                </a:solidFill>
-                <a:latin typeface="Calibri"/>
-              </a:rPr>
-              <a:t> (below).</a:t>
-            </a:r>
-          </a:p>
-          <a:p>
-            <a:pPr algn="l" marL="384048" indent="-384048">
-              <a:spcAft>
-                <a:spcPts val="979"/>
-              </a:spcAft>
-              <a:buChar char="•"/>
-            </a:pPr>
-            <a:r>
-              <a:rPr sz="2800" b="0" i="0">
-                <a:solidFill>
-                  <a:srgbClr val="22252A"/>
-                </a:solidFill>
-                <a:latin typeface="Calibri"/>
-              </a:rPr>
-              <a:t>FTIR EC compares well to absorption measurements (Fabs) at most SPARTAN sites, but not in Addis Ababa.</a:t>
-            </a:r>
-          </a:p>
-          <a:p>
-            <a:pPr algn="l" marL="384048" indent="-384048">
-              <a:spcAft>
-                <a:spcPts val="979"/>
-              </a:spcAft>
-              <a:buChar char="•"/>
-            </a:pPr>
-            <a:r>
-              <a:rPr sz="2800" b="1" i="0">
-                <a:solidFill>
-                  <a:srgbClr val="22252A"/>
-                </a:solidFill>
-                <a:latin typeface="Calibri"/>
-              </a:rPr>
-              <a:t>Addis Ababa</a:t>
-            </a:r>
-            <a:r>
-              <a:rPr sz="2800" b="0" i="0">
-                <a:solidFill>
-                  <a:srgbClr val="22252A"/>
-                </a:solidFill>
-                <a:latin typeface="Calibri"/>
-              </a:rPr>
-              <a:t>, capital of Ethiopia (about 2,400 m elevation, about 5 million people), has some of the highest EC in SPARTAN. Households cook and heat with wood and charcoal.</a:t>
-            </a:r>
-          </a:p>
-          <a:p>
-            <a:pPr algn="l" marL="384048" indent="-384048">
-              <a:spcAft>
-                <a:spcPts val="979"/>
-              </a:spcAft>
-              <a:buChar char="•"/>
-            </a:pPr>
-            <a:r>
-              <a:rPr sz="2800" b="0" i="0">
-                <a:solidFill>
-                  <a:srgbClr val="22252A"/>
-                </a:solidFill>
-                <a:latin typeface="Calibri"/>
-              </a:rPr>
-              <a:t>We use 189 Addis filters (Dec 2022 to Sep 2024) across three seasons: </a:t>
-            </a:r>
-            <a:r>
-              <a:rPr sz="2800" b="1" i="0">
-                <a:solidFill>
-                  <a:srgbClr val="22252A"/>
-                </a:solidFill>
-                <a:latin typeface="Calibri"/>
-              </a:rPr>
-              <a:t>Dry</a:t>
-            </a:r>
-            <a:r>
-              <a:rPr sz="2800" b="0" i="0">
-                <a:solidFill>
-                  <a:srgbClr val="22252A"/>
-                </a:solidFill>
-                <a:latin typeface="Calibri"/>
-              </a:rPr>
-              <a:t> (Bega, Oct to Feb), </a:t>
-            </a:r>
-            <a:r>
-              <a:rPr sz="2800" b="1" i="0">
-                <a:solidFill>
-                  <a:srgbClr val="22252A"/>
-                </a:solidFill>
-                <a:latin typeface="Calibri"/>
-              </a:rPr>
-              <a:t>Belg</a:t>
-            </a:r>
-            <a:r>
-              <a:rPr sz="2800" b="0" i="0">
-                <a:solidFill>
-                  <a:srgbClr val="22252A"/>
-                </a:solidFill>
-                <a:latin typeface="Calibri"/>
-              </a:rPr>
-              <a:t> short rains (Mar to May) and </a:t>
-            </a:r>
-            <a:r>
-              <a:rPr sz="2800" b="1" i="0">
-                <a:solidFill>
-                  <a:srgbClr val="22252A"/>
-                </a:solidFill>
-                <a:latin typeface="Calibri"/>
-              </a:rPr>
-              <a:t>Kiremt</a:t>
-            </a:r>
-            <a:r>
-              <a:rPr sz="2800" b="0" i="0">
-                <a:solidFill>
-                  <a:srgbClr val="22252A"/>
-                </a:solidFill>
-                <a:latin typeface="Calibri"/>
-              </a:rPr>
-              <a:t> long rains (Jun to Sep).</a:t>
-            </a:r>
-          </a:p>
-        </p:txBody>
-      </p:sp>
       <p:pic>
         <p:nvPicPr>
-          <p:cNvPr id="17" name="Picture 16" descr="f0_network_map.png"/>
+          <p:cNvPr id="12" name="Picture 11" descr="spartan_cyan.png"/>
           <p:cNvPicPr>
             <a:picLocks noChangeAspect="1"/>
           </p:cNvPicPr>
@@ -3821,8 +3429,8 @@
         </p:blipFill>
         <p:spPr>
           <a:xfrm>
-            <a:off x="2971800" y="13713460"/>
-            <a:ext cx="8138159" cy="3786386"/>
+            <a:off x="31272480" y="3611880"/>
+            <a:ext cx="6766560" cy="1583119"/>
           </a:xfrm>
           <a:prstGeom prst="rect">
             <a:avLst/>
@@ -3831,61 +3439,145 @@
       </p:pic>
       <p:sp>
         <p:nvSpPr>
-          <p:cNvPr id="18" name="TextBox 17"/>
-          <p:cNvSpPr txBox="1"/>
+          <p:cNvPr id="13" name="Rectangle 12"/>
+          <p:cNvSpPr/>
           <p:nvPr/>
         </p:nvSpPr>
         <p:spPr>
           <a:xfrm>
-            <a:off x="1051560" y="17545566"/>
-            <a:ext cx="11978640" cy="896620"/>
+            <a:off x="777240" y="6446520"/>
+            <a:ext cx="12527280" cy="34061400"/>
           </a:xfrm>
           <a:prstGeom prst="rect">
             <a:avLst/>
           </a:prstGeom>
-          <a:noFill/>
-        </p:spPr>
-        <p:txBody>
-          <a:bodyPr wrap="square" tIns="27432" bIns="27432">
-            <a:spAutoFit/>
-          </a:bodyPr>
-          <a:lstStyle/>
-          <a:p>
-            <a:pPr algn="l">
-              <a:spcAft>
-                <a:spcPts val="460"/>
-              </a:spcAft>
-            </a:pPr>
-            <a:r>
-              <a:rPr sz="2300" b="1" i="0">
-                <a:solidFill>
-                  <a:srgbClr val="55585E"/>
-                </a:solidFill>
-                <a:latin typeface="Calibri"/>
-              </a:rPr>
-              <a:t>Figure 1.</a:t>
-            </a:r>
-            <a:r>
-              <a:rPr sz="2300" b="0" i="0">
-                <a:solidFill>
-                  <a:srgbClr val="55585E"/>
-                </a:solidFill>
-                <a:latin typeface="Calibri"/>
-              </a:rPr>
-              <a:t> Where the filters come from. Grey: IMPROVE sites (US), which provide the calibration. Blue stars: SPARTAN sites, where the calibration is applied.</a:t>
-            </a:r>
-          </a:p>
-        </p:txBody>
-      </p:sp>
-      <p:sp>
-        <p:nvSpPr>
-          <p:cNvPr id="19" name="Rectangle 18"/>
+          <a:solidFill>
+            <a:srgbClr val="FFFFFF"/>
+          </a:solidFill>
+          <a:ln>
+            <a:noFill/>
+          </a:ln>
+          <a:effectLst/>
+        </p:spPr>
+        <p:style>
+          <a:lnRef idx="1">
+            <a:schemeClr val="accent1"/>
+          </a:lnRef>
+          <a:fillRef idx="3">
+            <a:schemeClr val="accent1"/>
+          </a:fillRef>
+          <a:effectRef idx="2">
+            <a:schemeClr val="accent1"/>
+          </a:effectRef>
+          <a:fontRef idx="minor">
+            <a:schemeClr val="lt1"/>
+          </a:fontRef>
+        </p:style>
+        <p:txBody>
+          <a:bodyPr rtlCol="0" anchor="ctr"/>
+          <a:lstStyle/>
+          <a:p>
+            <a:pPr algn="ctr"/>
+          </a:p>
+        </p:txBody>
+      </p:sp>
+      <p:sp>
+        <p:nvSpPr>
+          <p:cNvPr id="14" name="Rectangle 13"/>
           <p:cNvSpPr/>
           <p:nvPr/>
         </p:nvSpPr>
         <p:spPr>
           <a:xfrm>
-            <a:off x="777240" y="18670786"/>
+            <a:off x="13853159" y="6446520"/>
+            <a:ext cx="12527280" cy="34061400"/>
+          </a:xfrm>
+          <a:prstGeom prst="rect">
+            <a:avLst/>
+          </a:prstGeom>
+          <a:solidFill>
+            <a:srgbClr val="FFFFFF"/>
+          </a:solidFill>
+          <a:ln>
+            <a:noFill/>
+          </a:ln>
+          <a:effectLst/>
+        </p:spPr>
+        <p:style>
+          <a:lnRef idx="1">
+            <a:schemeClr val="accent1"/>
+          </a:lnRef>
+          <a:fillRef idx="3">
+            <a:schemeClr val="accent1"/>
+          </a:fillRef>
+          <a:effectRef idx="2">
+            <a:schemeClr val="accent1"/>
+          </a:effectRef>
+          <a:fontRef idx="minor">
+            <a:schemeClr val="lt1"/>
+          </a:fontRef>
+        </p:style>
+        <p:txBody>
+          <a:bodyPr rtlCol="0" anchor="ctr"/>
+          <a:lstStyle/>
+          <a:p>
+            <a:pPr algn="ctr"/>
+          </a:p>
+        </p:txBody>
+      </p:sp>
+      <p:sp>
+        <p:nvSpPr>
+          <p:cNvPr id="15" name="Rectangle 14"/>
+          <p:cNvSpPr/>
+          <p:nvPr/>
+        </p:nvSpPr>
+        <p:spPr>
+          <a:xfrm>
+            <a:off x="26929080" y="6446520"/>
+            <a:ext cx="12527280" cy="34061400"/>
+          </a:xfrm>
+          <a:prstGeom prst="rect">
+            <a:avLst/>
+          </a:prstGeom>
+          <a:solidFill>
+            <a:srgbClr val="FFFFFF"/>
+          </a:solidFill>
+          <a:ln>
+            <a:noFill/>
+          </a:ln>
+          <a:effectLst/>
+        </p:spPr>
+        <p:style>
+          <a:lnRef idx="1">
+            <a:schemeClr val="accent1"/>
+          </a:lnRef>
+          <a:fillRef idx="3">
+            <a:schemeClr val="accent1"/>
+          </a:fillRef>
+          <a:effectRef idx="2">
+            <a:schemeClr val="accent1"/>
+          </a:effectRef>
+          <a:fontRef idx="minor">
+            <a:schemeClr val="lt1"/>
+          </a:fontRef>
+        </p:style>
+        <p:txBody>
+          <a:bodyPr rtlCol="0" anchor="ctr"/>
+          <a:lstStyle/>
+          <a:p>
+            <a:pPr algn="ctr"/>
+          </a:p>
+        </p:txBody>
+      </p:sp>
+      <p:sp>
+        <p:nvSpPr>
+          <p:cNvPr id="16" name="Rectangle 15"/>
+          <p:cNvSpPr/>
+          <p:nvPr/>
+        </p:nvSpPr>
+        <p:spPr>
+          <a:xfrm>
+            <a:off x="777240" y="6446520"/>
             <a:ext cx="12527280" cy="777240"/>
           </a:xfrm>
           <a:prstGeom prst="rect">
@@ -3925,6 +3617,338 @@
                 </a:solidFill>
                 <a:latin typeface="Calibri"/>
               </a:rPr>
+              <a:t>Why elemental carbon in Addis Ababa?</a:t>
+            </a:r>
+          </a:p>
+        </p:txBody>
+      </p:sp>
+      <p:sp>
+        <p:nvSpPr>
+          <p:cNvPr id="17" name="TextBox 16"/>
+          <p:cNvSpPr txBox="1"/>
+          <p:nvPr/>
+        </p:nvSpPr>
+        <p:spPr>
+          <a:xfrm>
+            <a:off x="1051560" y="7406640"/>
+            <a:ext cx="11978640" cy="6306820"/>
+          </a:xfrm>
+          <a:prstGeom prst="rect">
+            <a:avLst/>
+          </a:prstGeom>
+          <a:noFill/>
+        </p:spPr>
+        <p:txBody>
+          <a:bodyPr wrap="square" tIns="27432" bIns="27432">
+            <a:spAutoFit/>
+          </a:bodyPr>
+          <a:lstStyle/>
+          <a:p>
+            <a:pPr algn="l" marL="384048" indent="-384048">
+              <a:spcAft>
+                <a:spcPts val="979"/>
+              </a:spcAft>
+              <a:buChar char="•"/>
+            </a:pPr>
+            <a:r>
+              <a:rPr sz="2800" b="1" i="0">
+                <a:solidFill>
+                  <a:srgbClr val="22252A"/>
+                </a:solidFill>
+                <a:latin typeface="Calibri"/>
+              </a:rPr>
+              <a:t>Elemental carbon (EC)</a:t>
+            </a:r>
+            <a:r>
+              <a:rPr sz="2800" b="0" i="0">
+                <a:solidFill>
+                  <a:srgbClr val="22252A"/>
+                </a:solidFill>
+                <a:latin typeface="Calibri"/>
+              </a:rPr>
+              <a:t> is the black, soot-like carbon from burning. It warms the climate and harms health.</a:t>
+            </a:r>
+          </a:p>
+          <a:p>
+            <a:pPr algn="l" marL="384048" indent="-384048">
+              <a:spcAft>
+                <a:spcPts val="979"/>
+              </a:spcAft>
+              <a:buChar char="•"/>
+            </a:pPr>
+            <a:r>
+              <a:rPr sz="2800" b="1" i="0">
+                <a:solidFill>
+                  <a:srgbClr val="22252A"/>
+                </a:solidFill>
+                <a:latin typeface="Calibri"/>
+              </a:rPr>
+              <a:t>SPARTAN</a:t>
+            </a:r>
+            <a:r>
+              <a:rPr sz="2800" b="0" i="0">
+                <a:solidFill>
+                  <a:srgbClr val="22252A"/>
+                </a:solidFill>
+                <a:latin typeface="Calibri"/>
+              </a:rPr>
+              <a:t> (Surface PARTiculate mAtter Network, www.spartan-network.org, Fig 1) samples particles onto filters in cities around the world, mostly in the Global South. It measures EC by </a:t>
+            </a:r>
+            <a:r>
+              <a:rPr sz="2800" b="1" i="0">
+                <a:solidFill>
+                  <a:srgbClr val="22252A"/>
+                </a:solidFill>
+                <a:latin typeface="Calibri"/>
+              </a:rPr>
+              <a:t>FTIR</a:t>
+            </a:r>
+            <a:r>
+              <a:rPr sz="2800" b="0" i="0">
+                <a:solidFill>
+                  <a:srgbClr val="22252A"/>
+                </a:solidFill>
+                <a:latin typeface="Calibri"/>
+              </a:rPr>
+              <a:t> (below).</a:t>
+            </a:r>
+          </a:p>
+          <a:p>
+            <a:pPr algn="l" marL="384048" indent="-384048">
+              <a:spcAft>
+                <a:spcPts val="979"/>
+              </a:spcAft>
+              <a:buChar char="•"/>
+            </a:pPr>
+            <a:r>
+              <a:rPr sz="2800" b="0" i="0">
+                <a:solidFill>
+                  <a:srgbClr val="22252A"/>
+                </a:solidFill>
+                <a:latin typeface="Calibri"/>
+              </a:rPr>
+              <a:t>FTIR EC compares well to absorption measurements (Fabs) at most SPARTAN sites, but not in Addis Ababa.</a:t>
+            </a:r>
+          </a:p>
+          <a:p>
+            <a:pPr algn="l" marL="384048" indent="-384048">
+              <a:spcAft>
+                <a:spcPts val="979"/>
+              </a:spcAft>
+              <a:buChar char="•"/>
+            </a:pPr>
+            <a:r>
+              <a:rPr sz="2800" b="1" i="0">
+                <a:solidFill>
+                  <a:srgbClr val="22252A"/>
+                </a:solidFill>
+                <a:latin typeface="Calibri"/>
+              </a:rPr>
+              <a:t>Addis Ababa</a:t>
+            </a:r>
+            <a:r>
+              <a:rPr sz="2800" b="0" i="0">
+                <a:solidFill>
+                  <a:srgbClr val="22252A"/>
+                </a:solidFill>
+                <a:latin typeface="Calibri"/>
+              </a:rPr>
+              <a:t>, capital of Ethiopia (about 2,400 m elevation, about 5 million people), has some of the highest EC in SPARTAN. Households cook and heat with wood and charcoal.</a:t>
+            </a:r>
+          </a:p>
+          <a:p>
+            <a:pPr algn="l" marL="384048" indent="-384048">
+              <a:spcAft>
+                <a:spcPts val="979"/>
+              </a:spcAft>
+              <a:buChar char="•"/>
+            </a:pPr>
+            <a:r>
+              <a:rPr sz="2800" b="0" i="0">
+                <a:solidFill>
+                  <a:srgbClr val="22252A"/>
+                </a:solidFill>
+                <a:latin typeface="Calibri"/>
+              </a:rPr>
+              <a:t>We use 189 Addis filters (Dec 2022 to Sep 2024) across three seasons: </a:t>
+            </a:r>
+            <a:r>
+              <a:rPr sz="2800" b="1" i="0">
+                <a:solidFill>
+                  <a:srgbClr val="22252A"/>
+                </a:solidFill>
+                <a:latin typeface="Calibri"/>
+              </a:rPr>
+              <a:t>Dry</a:t>
+            </a:r>
+            <a:r>
+              <a:rPr sz="2800" b="0" i="0">
+                <a:solidFill>
+                  <a:srgbClr val="22252A"/>
+                </a:solidFill>
+                <a:latin typeface="Calibri"/>
+              </a:rPr>
+              <a:t> (Bega, Oct to Feb), </a:t>
+            </a:r>
+            <a:r>
+              <a:rPr sz="2800" b="1" i="0">
+                <a:solidFill>
+                  <a:srgbClr val="22252A"/>
+                </a:solidFill>
+                <a:latin typeface="Calibri"/>
+              </a:rPr>
+              <a:t>Belg</a:t>
+            </a:r>
+            <a:r>
+              <a:rPr sz="2800" b="0" i="0">
+                <a:solidFill>
+                  <a:srgbClr val="22252A"/>
+                </a:solidFill>
+                <a:latin typeface="Calibri"/>
+              </a:rPr>
+              <a:t> short rains (Mar to May) and </a:t>
+            </a:r>
+            <a:r>
+              <a:rPr sz="2800" b="1" i="0">
+                <a:solidFill>
+                  <a:srgbClr val="22252A"/>
+                </a:solidFill>
+                <a:latin typeface="Calibri"/>
+              </a:rPr>
+              <a:t>Kiremt</a:t>
+            </a:r>
+            <a:r>
+              <a:rPr sz="2800" b="0" i="0">
+                <a:solidFill>
+                  <a:srgbClr val="22252A"/>
+                </a:solidFill>
+                <a:latin typeface="Calibri"/>
+              </a:rPr>
+              <a:t> long rains (Jun to Sep).</a:t>
+            </a:r>
+          </a:p>
+        </p:txBody>
+      </p:sp>
+      <p:pic>
+        <p:nvPicPr>
+          <p:cNvPr id="18" name="Picture 17" descr="f0_network_map.png"/>
+          <p:cNvPicPr>
+            <a:picLocks noChangeAspect="1"/>
+          </p:cNvPicPr>
+          <p:nvPr/>
+        </p:nvPicPr>
+        <p:blipFill>
+          <a:blip r:embed="rId8"/>
+          <a:stretch>
+            <a:fillRect/>
+          </a:stretch>
+        </p:blipFill>
+        <p:spPr>
+          <a:xfrm>
+            <a:off x="2971800" y="13713460"/>
+            <a:ext cx="8138159" cy="3786386"/>
+          </a:xfrm>
+          <a:prstGeom prst="rect">
+            <a:avLst/>
+          </a:prstGeom>
+        </p:spPr>
+      </p:pic>
+      <p:sp>
+        <p:nvSpPr>
+          <p:cNvPr id="19" name="TextBox 18"/>
+          <p:cNvSpPr txBox="1"/>
+          <p:nvPr/>
+        </p:nvSpPr>
+        <p:spPr>
+          <a:xfrm>
+            <a:off x="1051560" y="17545566"/>
+            <a:ext cx="11978640" cy="896620"/>
+          </a:xfrm>
+          <a:prstGeom prst="rect">
+            <a:avLst/>
+          </a:prstGeom>
+          <a:noFill/>
+        </p:spPr>
+        <p:txBody>
+          <a:bodyPr wrap="square" tIns="27432" bIns="27432">
+            <a:spAutoFit/>
+          </a:bodyPr>
+          <a:lstStyle/>
+          <a:p>
+            <a:pPr algn="l">
+              <a:spcAft>
+                <a:spcPts val="460"/>
+              </a:spcAft>
+            </a:pPr>
+            <a:r>
+              <a:rPr sz="2300" b="1" i="0">
+                <a:solidFill>
+                  <a:srgbClr val="55585E"/>
+                </a:solidFill>
+                <a:latin typeface="Calibri"/>
+              </a:rPr>
+              <a:t>Figure 1.</a:t>
+            </a:r>
+            <a:r>
+              <a:rPr sz="2300" b="0" i="0">
+                <a:solidFill>
+                  <a:srgbClr val="55585E"/>
+                </a:solidFill>
+                <a:latin typeface="Calibri"/>
+              </a:rPr>
+              <a:t> Where the filters come from. Grey: IMPROVE sites (US), which provide the calibration. Blue stars: SPARTAN sites, where the calibration is applied.</a:t>
+            </a:r>
+          </a:p>
+        </p:txBody>
+      </p:sp>
+      <p:sp>
+        <p:nvSpPr>
+          <p:cNvPr id="20" name="Rectangle 19"/>
+          <p:cNvSpPr/>
+          <p:nvPr/>
+        </p:nvSpPr>
+        <p:spPr>
+          <a:xfrm>
+            <a:off x="777240" y="18670786"/>
+            <a:ext cx="12527280" cy="777240"/>
+          </a:xfrm>
+          <a:prstGeom prst="rect">
+            <a:avLst/>
+          </a:prstGeom>
+          <a:solidFill>
+            <a:srgbClr val="1B365D"/>
+          </a:solidFill>
+          <a:ln>
+            <a:noFill/>
+          </a:ln>
+          <a:effectLst/>
+        </p:spPr>
+        <p:style>
+          <a:lnRef idx="1">
+            <a:schemeClr val="accent1"/>
+          </a:lnRef>
+          <a:fillRef idx="3">
+            <a:schemeClr val="accent1"/>
+          </a:fillRef>
+          <a:effectRef idx="2">
+            <a:schemeClr val="accent1"/>
+          </a:effectRef>
+          <a:fontRef idx="minor">
+            <a:schemeClr val="lt1"/>
+          </a:fontRef>
+        </p:style>
+        <p:txBody>
+          <a:bodyPr rtlCol="0" anchor="ctr" lIns="182880"/>
+          <a:lstStyle/>
+          <a:p>
+            <a:pPr algn="ctr"/>
+            <a:r>
+              <a:rPr sz="3800" b="1" i="0">
+                <a:solidFill>
+                  <a:srgbClr val="FFFFFF"/>
+                </a:solidFill>
+                <a:latin typeface="Calibri"/>
+              </a:rPr>
               <a:t>How FTIR measures EC: a calibration</a:t>
             </a:r>
           </a:p>
@@ -3932,7 +3956,7 @@
       </p:sp>
       <p:sp>
         <p:nvSpPr>
-          <p:cNvPr id="20" name="TextBox 19"/>
+          <p:cNvPr id="21" name="TextBox 20"/>
           <p:cNvSpPr txBox="1"/>
           <p:nvPr/>
         </p:nvSpPr>
@@ -4068,7 +4092,7 @@
       </p:sp>
       <p:sp>
         <p:nvSpPr>
-          <p:cNvPr id="21" name="Rounded Rectangle 20"/>
+          <p:cNvPr id="22" name="Rounded Rectangle 21"/>
           <p:cNvSpPr/>
           <p:nvPr/>
         </p:nvSpPr>
@@ -4161,7 +4185,7 @@
       </p:sp>
       <p:sp>
         <p:nvSpPr>
-          <p:cNvPr id="22" name="Right Arrow 21"/>
+          <p:cNvPr id="23" name="Right Arrow 22"/>
           <p:cNvSpPr/>
           <p:nvPr/>
         </p:nvSpPr>
@@ -4205,7 +4229,7 @@
       </p:sp>
       <p:sp>
         <p:nvSpPr>
-          <p:cNvPr id="23" name="Right Arrow 22"/>
+          <p:cNvPr id="24" name="Right Arrow 23"/>
           <p:cNvSpPr/>
           <p:nvPr/>
         </p:nvSpPr>
@@ -4249,7 +4273,7 @@
       </p:sp>
       <p:sp>
         <p:nvSpPr>
-          <p:cNvPr id="24" name="Rounded Rectangle 23"/>
+          <p:cNvPr id="25" name="Rounded Rectangle 24"/>
           <p:cNvSpPr/>
           <p:nvPr/>
         </p:nvSpPr>
@@ -4327,7 +4351,7 @@
       </p:sp>
       <p:sp>
         <p:nvSpPr>
-          <p:cNvPr id="25" name="Rounded Rectangle 24"/>
+          <p:cNvPr id="26" name="Rounded Rectangle 25"/>
           <p:cNvSpPr/>
           <p:nvPr/>
         </p:nvSpPr>
@@ -4405,7 +4429,7 @@
       </p:sp>
       <p:sp>
         <p:nvSpPr>
-          <p:cNvPr id="26" name="Right Arrow 25"/>
+          <p:cNvPr id="27" name="Right Arrow 26"/>
           <p:cNvSpPr/>
           <p:nvPr/>
         </p:nvSpPr>
@@ -4449,7 +4473,7 @@
       </p:sp>
       <p:sp>
         <p:nvSpPr>
-          <p:cNvPr id="27" name="Right Arrow 26"/>
+          <p:cNvPr id="28" name="Right Arrow 27"/>
           <p:cNvSpPr/>
           <p:nvPr/>
         </p:nvSpPr>
@@ -4493,7 +4517,7 @@
       </p:sp>
       <p:sp>
         <p:nvSpPr>
-          <p:cNvPr id="28" name="Rounded Rectangle 27"/>
+          <p:cNvPr id="29" name="Rounded Rectangle 28"/>
           <p:cNvSpPr/>
           <p:nvPr/>
         </p:nvSpPr>
@@ -4586,7 +4610,7 @@
       </p:sp>
       <p:sp>
         <p:nvSpPr>
-          <p:cNvPr id="29" name="Down Arrow 28"/>
+          <p:cNvPr id="30" name="Down Arrow 29"/>
           <p:cNvSpPr/>
           <p:nvPr/>
         </p:nvSpPr>
@@ -4630,7 +4654,7 @@
       </p:sp>
       <p:sp>
         <p:nvSpPr>
-          <p:cNvPr id="30" name="Rounded Rectangle 29"/>
+          <p:cNvPr id="31" name="Rounded Rectangle 30"/>
           <p:cNvSpPr/>
           <p:nvPr/>
         </p:nvSpPr>
@@ -4723,7 +4747,7 @@
       </p:sp>
       <p:sp>
         <p:nvSpPr>
-          <p:cNvPr id="31" name="TextBox 30"/>
+          <p:cNvPr id="32" name="TextBox 31"/>
           <p:cNvSpPr txBox="1"/>
           <p:nvPr/>
         </p:nvSpPr>
@@ -4771,7 +4795,7 @@
       </p:sp>
       <p:sp>
         <p:nvSpPr>
-          <p:cNvPr id="32" name="Rectangle 31"/>
+          <p:cNvPr id="33" name="Rectangle 32"/>
           <p:cNvSpPr/>
           <p:nvPr/>
         </p:nvSpPr>
@@ -4817,7 +4841,7 @@
       </p:sp>
       <p:sp>
         <p:nvSpPr>
-          <p:cNvPr id="33" name="TextBox 32"/>
+          <p:cNvPr id="34" name="TextBox 33"/>
           <p:cNvSpPr txBox="1"/>
           <p:nvPr/>
         </p:nvSpPr>
@@ -4865,7 +4889,7 @@
       </p:sp>
       <p:sp>
         <p:nvSpPr>
-          <p:cNvPr id="34" name="Rectangle 33"/>
+          <p:cNvPr id="35" name="Rectangle 34"/>
           <p:cNvSpPr/>
           <p:nvPr/>
         </p:nvSpPr>
@@ -4918,7 +4942,7 @@
       </p:sp>
       <p:sp>
         <p:nvSpPr>
-          <p:cNvPr id="35" name="TextBox 34"/>
+          <p:cNvPr id="36" name="TextBox 35"/>
           <p:cNvSpPr txBox="1"/>
           <p:nvPr/>
         </p:nvSpPr>
@@ -5159,7 +5183,7 @@
       </p:sp>
       <p:sp>
         <p:nvSpPr>
-          <p:cNvPr id="36" name="TextBox 35"/>
+          <p:cNvPr id="37" name="TextBox 36"/>
           <p:cNvSpPr txBox="1"/>
           <p:nvPr/>
         </p:nvSpPr>
@@ -5207,7 +5231,7 @@
       </p:sp>
       <p:sp>
         <p:nvSpPr>
-          <p:cNvPr id="37" name="Rectangle 36"/>
+          <p:cNvPr id="38" name="Rectangle 37"/>
           <p:cNvSpPr/>
           <p:nvPr/>
         </p:nvSpPr>
@@ -5260,132 +5284,7 @@
       </p:sp>
       <p:pic>
         <p:nvPicPr>
-          <p:cNvPr id="38" name="Picture 37" descr="fp_addis_air.png"/>
-          <p:cNvPicPr>
-            <a:picLocks noChangeAspect="1"/>
-          </p:cNvPicPr>
-          <p:nvPr/>
-        </p:nvPicPr>
-        <p:blipFill>
-          <a:blip r:embed="rId8"/>
-          <a:stretch>
-            <a:fillRect/>
-          </a:stretch>
-        </p:blipFill>
-        <p:spPr>
-          <a:xfrm>
-            <a:off x="15956280" y="7406640"/>
-            <a:ext cx="8321040" cy="5134334"/>
-          </a:xfrm>
-          <a:prstGeom prst="rect">
-            <a:avLst/>
-          </a:prstGeom>
-        </p:spPr>
-      </p:pic>
-      <p:sp>
-        <p:nvSpPr>
-          <p:cNvPr id="39" name="TextBox 38"/>
-          <p:cNvSpPr txBox="1"/>
-          <p:nvPr/>
-        </p:nvSpPr>
-        <p:spPr>
-          <a:xfrm>
-            <a:off x="14127480" y="12586694"/>
-            <a:ext cx="11978640" cy="1247139"/>
-          </a:xfrm>
-          <a:prstGeom prst="rect">
-            <a:avLst/>
-          </a:prstGeom>
-          <a:noFill/>
-        </p:spPr>
-        <p:txBody>
-          <a:bodyPr wrap="square" tIns="27432" bIns="27432">
-            <a:spAutoFit/>
-          </a:bodyPr>
-          <a:lstStyle/>
-          <a:p>
-            <a:pPr algn="l">
-              <a:spcAft>
-                <a:spcPts val="460"/>
-              </a:spcAft>
-            </a:pPr>
-            <a:r>
-              <a:rPr sz="2300" b="1" i="0">
-                <a:solidFill>
-                  <a:srgbClr val="55585E"/>
-                </a:solidFill>
-                <a:latin typeface="Calibri"/>
-              </a:rPr>
-              <a:t>Figure 3.</a:t>
-            </a:r>
-            <a:r>
-              <a:rPr sz="2300" b="0" i="0">
-                <a:solidFill>
-                  <a:srgbClr val="55585E"/>
-                </a:solidFill>
-                <a:latin typeface="Calibri"/>
-              </a:rPr>
-              <a:t> Addis medians by season (bars on EC: interquartile range). EC is 4.3 to 5.6 µg/m³ and 19 to 25% of PM2.5 in every season, against about 4% for a typical IMPROVE filter.</a:t>
-            </a:r>
-          </a:p>
-        </p:txBody>
-      </p:sp>
-      <p:sp>
-        <p:nvSpPr>
-          <p:cNvPr id="40" name="Rectangle 39"/>
-          <p:cNvSpPr/>
-          <p:nvPr/>
-        </p:nvSpPr>
-        <p:spPr>
-          <a:xfrm>
-            <a:off x="13853159" y="14062434"/>
-            <a:ext cx="12527280" cy="777240"/>
-          </a:xfrm>
-          <a:prstGeom prst="rect">
-            <a:avLst/>
-          </a:prstGeom>
-          <a:solidFill>
-            <a:srgbClr val="1B365D"/>
-          </a:solidFill>
-          <a:ln>
-            <a:noFill/>
-          </a:ln>
-          <a:effectLst/>
-        </p:spPr>
-        <p:style>
-          <a:lnRef idx="1">
-            <a:schemeClr val="accent1"/>
-          </a:lnRef>
-          <a:fillRef idx="3">
-            <a:schemeClr val="accent1"/>
-          </a:fillRef>
-          <a:effectRef idx="2">
-            <a:schemeClr val="accent1"/>
-          </a:effectRef>
-          <a:fontRef idx="minor">
-            <a:schemeClr val="lt1"/>
-          </a:fontRef>
-        </p:style>
-        <p:txBody>
-          <a:bodyPr rtlCol="0" anchor="ctr" lIns="182880"/>
-          <a:lstStyle/>
-          <a:p>
-            <a:pPr algn="ctr"/>
-            <a:r>
-              <a:rPr sz="3800" b="1" i="0">
-                <a:solidFill>
-                  <a:srgbClr val="FFFFFF"/>
-                </a:solidFill>
-                <a:latin typeface="Calibri"/>
-              </a:rPr>
-              <a:t>The problem: FTIR EC is poorly predicted but well correlated</a:t>
-            </a:r>
-          </a:p>
-        </p:txBody>
-      </p:sp>
-      <p:pic>
-        <p:nvPicPr>
-          <p:cNvPr id="41" name="Picture 40" descr="fp_problem.png"/>
+          <p:cNvPr id="39" name="Picture 38" descr="fp_addis_air.png"/>
           <p:cNvPicPr>
             <a:picLocks noChangeAspect="1"/>
           </p:cNvPicPr>
@@ -5399,8 +5298,8 @@
         </p:blipFill>
         <p:spPr>
           <a:xfrm>
-            <a:off x="14127480" y="15022554"/>
-            <a:ext cx="11978640" cy="5980830"/>
+            <a:off x="15956280" y="7406640"/>
+            <a:ext cx="8321040" cy="5134334"/>
           </a:xfrm>
           <a:prstGeom prst="rect">
             <a:avLst/>
@@ -5409,14 +5308,14 @@
       </p:pic>
       <p:sp>
         <p:nvSpPr>
-          <p:cNvPr id="42" name="TextBox 41"/>
+          <p:cNvPr id="40" name="TextBox 39"/>
           <p:cNvSpPr txBox="1"/>
           <p:nvPr/>
         </p:nvSpPr>
         <p:spPr>
           <a:xfrm>
-            <a:off x="14127480" y="21049105"/>
-            <a:ext cx="11978640" cy="1948180"/>
+            <a:off x="14127480" y="12586694"/>
+            <a:ext cx="11978640" cy="1247139"/>
           </a:xfrm>
           <a:prstGeom prst="rect">
             <a:avLst/>
@@ -5441,7 +5340,7 @@
                 </a:solidFill>
                 <a:latin typeface="Calibri"/>
               </a:rPr>
-              <a:t>Figure 4.</a:t>
+              <a:t>Figure 3.</a:t>
             </a:r>
             <a:r>
               <a:rPr sz="2300" b="0" i="0">
@@ -5450,56 +5349,20 @@
                 </a:solidFill>
                 <a:latin typeface="Calibri"/>
               </a:rPr>
-              <a:t> Each point is one filter; dotted line: 1:1. </a:t>
-            </a:r>
-            <a:r>
-              <a:rPr sz="2300" b="1" i="0">
-                <a:solidFill>
-                  <a:srgbClr val="55585E"/>
-                </a:solidFill>
-                <a:latin typeface="Calibri"/>
-              </a:rPr>
-              <a:t>IMPROVE:</a:t>
-            </a:r>
-            <a:r>
-              <a:rPr sz="2300" b="0" i="0">
-                <a:solidFill>
-                  <a:srgbClr val="55585E"/>
-                </a:solidFill>
-                <a:latin typeface="Calibri"/>
-              </a:rPr>
-              <a:t> 2,078 filters, FTIR against TOR EC: slope near 1, intercept near 0. </a:t>
-            </a:r>
-            <a:r>
-              <a:rPr sz="2300" b="1" i="0">
-                <a:solidFill>
-                  <a:srgbClr val="55585E"/>
-                </a:solidFill>
-                <a:latin typeface="Calibri"/>
-              </a:rPr>
-              <a:t>SPARTAN:</a:t>
-            </a:r>
-            <a:r>
-              <a:rPr sz="2300" b="0" i="0">
-                <a:solidFill>
-                  <a:srgbClr val="55585E"/>
-                </a:solidFill>
-                <a:latin typeface="Calibri"/>
-              </a:rPr>
-              <a:t> FTIR against HIPS EC. The other SPARTAN sites together are predicted reasonably (grey data points and grey line); Addis alone is well correlated with the wrong slope and intercept (2.3x -6.1). Every season is off (slopes 1.4 to 2.2).</a:t>
-            </a:r>
-          </a:p>
-        </p:txBody>
-      </p:sp>
-      <p:sp>
-        <p:nvSpPr>
-          <p:cNvPr id="43" name="Rectangle 42"/>
+              <a:t> Addis medians by season (bars on EC: interquartile range). EC is 4.3 to 5.6 µg/m³ and 19 to 25% of PM2.5 in every season, against about 4% for a typical IMPROVE filter.</a:t>
+            </a:r>
+          </a:p>
+        </p:txBody>
+      </p:sp>
+      <p:sp>
+        <p:nvSpPr>
+          <p:cNvPr id="41" name="Rectangle 40"/>
           <p:cNvSpPr/>
           <p:nvPr/>
         </p:nvSpPr>
         <p:spPr>
           <a:xfrm>
-            <a:off x="13853159" y="23225885"/>
+            <a:off x="13853159" y="14062434"/>
             <a:ext cx="12527280" cy="777240"/>
           </a:xfrm>
           <a:prstGeom prst="rect">
@@ -5539,71 +5402,14 @@
                 </a:solidFill>
                 <a:latin typeface="Calibri"/>
               </a:rPr>
-              <a:t>IMPROVE spectra that look like Addis spectra fail too</a:t>
-            </a:r>
-          </a:p>
-        </p:txBody>
-      </p:sp>
-      <p:sp>
-        <p:nvSpPr>
-          <p:cNvPr id="44" name="TextBox 43"/>
-          <p:cNvSpPr txBox="1"/>
-          <p:nvPr/>
-        </p:nvSpPr>
-        <p:spPr>
-          <a:xfrm>
-            <a:off x="14127480" y="24186005"/>
-            <a:ext cx="11978640" cy="1045209"/>
-          </a:xfrm>
-          <a:prstGeom prst="rect">
-            <a:avLst/>
-          </a:prstGeom>
-          <a:noFill/>
-        </p:spPr>
-        <p:txBody>
-          <a:bodyPr wrap="square" tIns="27432" bIns="27432">
-            <a:spAutoFit/>
-          </a:bodyPr>
-          <a:lstStyle/>
-          <a:p>
-            <a:pPr algn="l">
-              <a:spcAft>
-                <a:spcPts val="910"/>
-              </a:spcAft>
-            </a:pPr>
-            <a:r>
-              <a:rPr sz="2600" b="0" i="0">
-                <a:solidFill>
-                  <a:srgbClr val="22252A"/>
-                </a:solidFill>
-                <a:latin typeface="Calibri"/>
-              </a:rPr>
-              <a:t>From the IMPROVE filters we picked the 97 whose </a:t>
-            </a:r>
-            <a:r>
-              <a:rPr sz="2600" b="1" i="0">
-                <a:solidFill>
-                  <a:srgbClr val="22252A"/>
-                </a:solidFill>
-                <a:latin typeface="Calibri"/>
-              </a:rPr>
-              <a:t>spectra most resemble the Addis spectra</a:t>
-            </a:r>
-            <a:r>
-              <a:rPr sz="2600" b="0" i="0">
-                <a:solidFill>
-                  <a:srgbClr val="22252A"/>
-                </a:solidFill>
-                <a:latin typeface="Calibri"/>
-              </a:rPr>
-              <a:t>. Many are smoke-affected.</a:t>
+              <a:t>The problem: FTIR EC is poorly predicted but well correlated</a:t>
             </a:r>
           </a:p>
         </p:txBody>
       </p:sp>
       <p:pic>
         <p:nvPicPr>
-          <p:cNvPr id="45" name="Picture 44" descr="fp_analogs.png"/>
+          <p:cNvPr id="42" name="Picture 41" descr="fp_problem.png"/>
           <p:cNvPicPr>
             <a:picLocks noChangeAspect="1"/>
           </p:cNvPicPr>
@@ -5617,7 +5423,7 @@
         </p:blipFill>
         <p:spPr>
           <a:xfrm>
-            <a:off x="14127480" y="25276935"/>
+            <a:off x="14127480" y="15022554"/>
             <a:ext cx="11978640" cy="5980830"/>
           </a:xfrm>
           <a:prstGeom prst="rect">
@@ -5627,14 +5433,14 @@
       </p:pic>
       <p:sp>
         <p:nvSpPr>
-          <p:cNvPr id="46" name="TextBox 45"/>
+          <p:cNvPr id="43" name="TextBox 42"/>
           <p:cNvSpPr txBox="1"/>
           <p:nvPr/>
         </p:nvSpPr>
         <p:spPr>
           <a:xfrm>
-            <a:off x="14127480" y="31303485"/>
-            <a:ext cx="11978640" cy="1597659"/>
+            <a:off x="14127480" y="21049105"/>
+            <a:ext cx="11978640" cy="1948180"/>
           </a:xfrm>
           <a:prstGeom prst="rect">
             <a:avLst/>
@@ -5659,7 +5465,7 @@
                 </a:solidFill>
                 <a:latin typeface="Calibri"/>
               </a:rPr>
-              <a:t>Figure 5.</a:t>
+              <a:t>Figure 4.</a:t>
             </a:r>
             <a:r>
               <a:rPr sz="2300" b="0" i="0">
@@ -5668,20 +5474,56 @@
                 </a:solidFill>
                 <a:latin typeface="Calibri"/>
               </a:rPr>
-              <a:t> Grey: all IMPROVE filters; red: the 97 most like Addis. TOR and HIPS agree on them, but the baseline-corrected FTIR calibration (as in Figure 4, IMPROVE, and Figure 7, right) predicts them poorly, at IMPROVE concentrations. Same calibration; only the samples changed.</a:t>
-            </a:r>
-          </a:p>
-        </p:txBody>
-      </p:sp>
-      <p:sp>
-        <p:nvSpPr>
-          <p:cNvPr id="47" name="Rectangle 46"/>
+              <a:t> Each point is one filter; dotted line: 1:1. </a:t>
+            </a:r>
+            <a:r>
+              <a:rPr sz="2300" b="1" i="0">
+                <a:solidFill>
+                  <a:srgbClr val="55585E"/>
+                </a:solidFill>
+                <a:latin typeface="Calibri"/>
+              </a:rPr>
+              <a:t>IMPROVE:</a:t>
+            </a:r>
+            <a:r>
+              <a:rPr sz="2300" b="0" i="0">
+                <a:solidFill>
+                  <a:srgbClr val="55585E"/>
+                </a:solidFill>
+                <a:latin typeface="Calibri"/>
+              </a:rPr>
+              <a:t> 2,078 filters, FTIR against TOR EC: slope near 1, intercept near 0. </a:t>
+            </a:r>
+            <a:r>
+              <a:rPr sz="2300" b="1" i="0">
+                <a:solidFill>
+                  <a:srgbClr val="55585E"/>
+                </a:solidFill>
+                <a:latin typeface="Calibri"/>
+              </a:rPr>
+              <a:t>SPARTAN:</a:t>
+            </a:r>
+            <a:r>
+              <a:rPr sz="2300" b="0" i="0">
+                <a:solidFill>
+                  <a:srgbClr val="55585E"/>
+                </a:solidFill>
+                <a:latin typeface="Calibri"/>
+              </a:rPr>
+              <a:t> FTIR against HIPS EC. The other SPARTAN sites together are predicted reasonably (grey data points and grey line); Addis alone is well correlated with the wrong slope and intercept (2.3x -6.1). Every season is off (slopes 1.4 to 2.2).</a:t>
+            </a:r>
+          </a:p>
+        </p:txBody>
+      </p:sp>
+      <p:sp>
+        <p:nvSpPr>
+          <p:cNvPr id="44" name="Rectangle 43"/>
           <p:cNvSpPr/>
           <p:nvPr/>
         </p:nvSpPr>
         <p:spPr>
           <a:xfrm>
-            <a:off x="13853159" y="33129745"/>
+            <a:off x="13853159" y="23225885"/>
             <a:ext cx="12527280" cy="777240"/>
           </a:xfrm>
           <a:prstGeom prst="rect">
@@ -5721,14 +5563,71 @@
                 </a:solidFill>
                 <a:latin typeface="Calibri"/>
               </a:rPr>
-              <a:t>Addis filters carry far more EC than IMPROVE filters</a:t>
+              <a:t>IMPROVE spectra that look like Addis spectra fail too</a:t>
+            </a:r>
+          </a:p>
+        </p:txBody>
+      </p:sp>
+      <p:sp>
+        <p:nvSpPr>
+          <p:cNvPr id="45" name="TextBox 44"/>
+          <p:cNvSpPr txBox="1"/>
+          <p:nvPr/>
+        </p:nvSpPr>
+        <p:spPr>
+          <a:xfrm>
+            <a:off x="14127480" y="24186005"/>
+            <a:ext cx="11978640" cy="1045209"/>
+          </a:xfrm>
+          <a:prstGeom prst="rect">
+            <a:avLst/>
+          </a:prstGeom>
+          <a:noFill/>
+        </p:spPr>
+        <p:txBody>
+          <a:bodyPr wrap="square" tIns="27432" bIns="27432">
+            <a:spAutoFit/>
+          </a:bodyPr>
+          <a:lstStyle/>
+          <a:p>
+            <a:pPr algn="l">
+              <a:spcAft>
+                <a:spcPts val="910"/>
+              </a:spcAft>
+            </a:pPr>
+            <a:r>
+              <a:rPr sz="2600" b="0" i="0">
+                <a:solidFill>
+                  <a:srgbClr val="22252A"/>
+                </a:solidFill>
+                <a:latin typeface="Calibri"/>
+              </a:rPr>
+              <a:t>From the IMPROVE filters we picked the 97 whose </a:t>
+            </a:r>
+            <a:r>
+              <a:rPr sz="2600" b="1" i="0">
+                <a:solidFill>
+                  <a:srgbClr val="22252A"/>
+                </a:solidFill>
+                <a:latin typeface="Calibri"/>
+              </a:rPr>
+              <a:t>spectra most resemble the Addis spectra</a:t>
+            </a:r>
+            <a:r>
+              <a:rPr sz="2600" b="0" i="0">
+                <a:solidFill>
+                  <a:srgbClr val="22252A"/>
+                </a:solidFill>
+                <a:latin typeface="Calibri"/>
+              </a:rPr>
+              <a:t>. Many are smoke-affected.</a:t>
             </a:r>
           </a:p>
         </p:txBody>
       </p:sp>
       <p:pic>
         <p:nvPicPr>
-          <p:cNvPr id="48" name="Picture 47" descr="fp_loading.png"/>
+          <p:cNvPr id="46" name="Picture 45" descr="fp_analogs.png"/>
           <p:cNvPicPr>
             <a:picLocks noChangeAspect="1"/>
           </p:cNvPicPr>
@@ -5742,8 +5641,8 @@
         </p:blipFill>
         <p:spPr>
           <a:xfrm>
-            <a:off x="14493240" y="34089865"/>
-            <a:ext cx="11247119" cy="4726416"/>
+            <a:off x="14127480" y="25276935"/>
+            <a:ext cx="11978640" cy="5980830"/>
           </a:xfrm>
           <a:prstGeom prst="rect">
             <a:avLst/>
@@ -5752,14 +5651,14 @@
       </p:pic>
       <p:sp>
         <p:nvSpPr>
-          <p:cNvPr id="49" name="TextBox 48"/>
+          <p:cNvPr id="47" name="TextBox 46"/>
           <p:cNvSpPr txBox="1"/>
           <p:nvPr/>
         </p:nvSpPr>
         <p:spPr>
           <a:xfrm>
-            <a:off x="14127480" y="38862001"/>
-            <a:ext cx="11978640" cy="1247139"/>
+            <a:off x="14127480" y="31303485"/>
+            <a:ext cx="11978640" cy="1597659"/>
           </a:xfrm>
           <a:prstGeom prst="rect">
             <a:avLst/>
@@ -5784,7 +5683,7 @@
                 </a:solidFill>
                 <a:latin typeface="Calibri"/>
               </a:rPr>
-              <a:t>Figure 6.</a:t>
+              <a:t>Figure 5.</a:t>
             </a:r>
             <a:r>
               <a:rPr sz="2300" b="0" i="0">
@@ -5793,20 +5692,20 @@
                 </a:solidFill>
                 <a:latin typeface="Calibri"/>
               </a:rPr>
-              <a:t> EC on one filter, from each filter's own volume of air (flow × sampling time). The typical Addis filter carries about 9× the EC of a typical IMPROVE calibration filter, and 79% are above the IMPROVE 99th percentile.</a:t>
-            </a:r>
-          </a:p>
-        </p:txBody>
-      </p:sp>
-      <p:sp>
-        <p:nvSpPr>
-          <p:cNvPr id="50" name="Rectangle 49"/>
+              <a:t> Grey: all IMPROVE filters; red: the 97 most like Addis. TOR and HIPS agree on them, but the baseline-corrected FTIR calibration (as in Figure 4, IMPROVE, and Figure 7, right) predicts them poorly, at IMPROVE concentrations. Same calibration; only the samples changed.</a:t>
+            </a:r>
+          </a:p>
+        </p:txBody>
+      </p:sp>
+      <p:sp>
+        <p:nvSpPr>
+          <p:cNvPr id="48" name="Rectangle 47"/>
           <p:cNvSpPr/>
           <p:nvPr/>
         </p:nvSpPr>
         <p:spPr>
           <a:xfrm>
-            <a:off x="26929080" y="6446520"/>
+            <a:off x="13853159" y="33129745"/>
             <a:ext cx="12527280" cy="777240"/>
           </a:xfrm>
           <a:prstGeom prst="rect">
@@ -5846,62 +5745,14 @@
                 </a:solidFill>
                 <a:latin typeface="Calibri"/>
               </a:rPr>
-              <a:t>Toward a better calibration (work in progress)</a:t>
-            </a:r>
-          </a:p>
-        </p:txBody>
-      </p:sp>
-      <p:sp>
-        <p:nvSpPr>
-          <p:cNvPr id="51" name="TextBox 50"/>
-          <p:cNvSpPr txBox="1"/>
-          <p:nvPr/>
-        </p:nvSpPr>
-        <p:spPr>
-          <a:xfrm>
-            <a:off x="27203400" y="7406640"/>
-            <a:ext cx="11978640" cy="648970"/>
-          </a:xfrm>
-          <a:prstGeom prst="rect">
-            <a:avLst/>
-          </a:prstGeom>
-          <a:noFill/>
-        </p:spPr>
-        <p:txBody>
-          <a:bodyPr wrap="square" tIns="27432" bIns="27432">
-            <a:spAutoFit/>
-          </a:bodyPr>
-          <a:lstStyle/>
-          <a:p>
-            <a:pPr algn="l">
-              <a:spcAft>
-                <a:spcPts val="910"/>
-              </a:spcAft>
-            </a:pPr>
-            <a:r>
-              <a:rPr sz="2600" b="1" i="0">
-                <a:solidFill>
-                  <a:srgbClr val="22252A"/>
-                </a:solidFill>
-                <a:latin typeface="Calibri"/>
-              </a:rPr>
-              <a:t>Step 1. Baseline correction of the spectra</a:t>
-            </a:r>
-            <a:r>
-              <a:rPr sz="2600" b="0" i="0">
-                <a:solidFill>
-                  <a:srgbClr val="22252A"/>
-                </a:solidFill>
-                <a:latin typeface="Calibri"/>
-              </a:rPr>
-              <a:t>, the biggest gain so far.</a:t>
+              <a:t>Addis filters carry far more EC than IMPROVE filters</a:t>
             </a:r>
           </a:p>
         </p:txBody>
       </p:sp>
       <p:pic>
         <p:nvPicPr>
-          <p:cNvPr id="52" name="Picture 51" descr="fp_baseline.png"/>
+          <p:cNvPr id="49" name="Picture 48" descr="fp_loading.png"/>
           <p:cNvPicPr>
             <a:picLocks noChangeAspect="1"/>
           </p:cNvPicPr>
@@ -5915,8 +5766,8 @@
         </p:blipFill>
         <p:spPr>
           <a:xfrm>
-            <a:off x="27203400" y="8101330"/>
-            <a:ext cx="11978640" cy="6035683"/>
+            <a:off x="14493240" y="34089865"/>
+            <a:ext cx="11247119" cy="4726416"/>
           </a:xfrm>
           <a:prstGeom prst="rect">
             <a:avLst/>
@@ -5925,14 +5776,14 @@
       </p:pic>
       <p:sp>
         <p:nvSpPr>
-          <p:cNvPr id="53" name="TextBox 52"/>
+          <p:cNvPr id="50" name="TextBox 49"/>
           <p:cNvSpPr txBox="1"/>
           <p:nvPr/>
         </p:nvSpPr>
         <p:spPr>
           <a:xfrm>
-            <a:off x="27203400" y="14182733"/>
-            <a:ext cx="11978640" cy="896620"/>
+            <a:off x="14127480" y="38862001"/>
+            <a:ext cx="11978640" cy="1247139"/>
           </a:xfrm>
           <a:prstGeom prst="rect">
             <a:avLst/>
@@ -5957,7 +5808,7 @@
                 </a:solidFill>
                 <a:latin typeface="Calibri"/>
               </a:rPr>
-              <a:t>Figure 7.</a:t>
+              <a:t>Figure 6.</a:t>
             </a:r>
             <a:r>
               <a:rPr sz="2300" b="0" i="0">
@@ -5966,21 +5817,74 @@
                 </a:solidFill>
                 <a:latin typeface="Calibri"/>
               </a:rPr>
-              <a:t> Same Addis filters, same axes as Figure 4. Correcting the baseline moves the intercept from -6.1 to -1.2 µg/m³, but the slope drops to 0.59.</a:t>
-            </a:r>
-          </a:p>
-        </p:txBody>
-      </p:sp>
-      <p:sp>
-        <p:nvSpPr>
-          <p:cNvPr id="54" name="TextBox 53"/>
+              <a:t> EC on one filter, from each filter's own volume of air (flow × sampling time). The typical Addis filter carries about 9× the EC of a typical IMPROVE calibration filter, and 79% are above the IMPROVE 99th percentile.</a:t>
+            </a:r>
+          </a:p>
+        </p:txBody>
+      </p:sp>
+      <p:sp>
+        <p:nvSpPr>
+          <p:cNvPr id="51" name="Rectangle 50"/>
+          <p:cNvSpPr/>
+          <p:nvPr/>
+        </p:nvSpPr>
+        <p:spPr>
+          <a:xfrm>
+            <a:off x="26929080" y="6446520"/>
+            <a:ext cx="12527280" cy="777240"/>
+          </a:xfrm>
+          <a:prstGeom prst="rect">
+            <a:avLst/>
+          </a:prstGeom>
+          <a:solidFill>
+            <a:srgbClr val="1B365D"/>
+          </a:solidFill>
+          <a:ln>
+            <a:noFill/>
+          </a:ln>
+          <a:effectLst/>
+        </p:spPr>
+        <p:style>
+          <a:lnRef idx="1">
+            <a:schemeClr val="accent1"/>
+          </a:lnRef>
+          <a:fillRef idx="3">
+            <a:schemeClr val="accent1"/>
+          </a:fillRef>
+          <a:effectRef idx="2">
+            <a:schemeClr val="accent1"/>
+          </a:effectRef>
+          <a:fontRef idx="minor">
+            <a:schemeClr val="lt1"/>
+          </a:fontRef>
+        </p:style>
+        <p:txBody>
+          <a:bodyPr rtlCol="0" anchor="ctr" lIns="182880"/>
+          <a:lstStyle/>
+          <a:p>
+            <a:pPr algn="ctr"/>
+            <a:r>
+              <a:rPr sz="3800" b="1" i="0">
+                <a:solidFill>
+                  <a:srgbClr val="FFFFFF"/>
+                </a:solidFill>
+                <a:latin typeface="Calibri"/>
+              </a:rPr>
+              <a:t>Toward a better calibration (work in progress)</a:t>
+            </a:r>
+          </a:p>
+        </p:txBody>
+      </p:sp>
+      <p:sp>
+        <p:nvSpPr>
+          <p:cNvPr id="52" name="TextBox 51"/>
           <p:cNvSpPr txBox="1"/>
           <p:nvPr/>
         </p:nvSpPr>
         <p:spPr>
           <a:xfrm>
-            <a:off x="27203400" y="15262233"/>
-            <a:ext cx="11978640" cy="1045209"/>
+            <a:off x="27203400" y="7406640"/>
+            <a:ext cx="11978640" cy="648970"/>
           </a:xfrm>
           <a:prstGeom prst="rect">
             <a:avLst/>
@@ -6005,7 +5909,7 @@
                 </a:solidFill>
                 <a:latin typeface="Calibri"/>
               </a:rPr>
-              <a:t>Step 2. Test thousands of calibrations</a:t>
+              <a:t>Step 1. Baseline correction of the spectra</a:t>
             </a:r>
             <a:r>
               <a:rPr sz="2600" b="0" i="0">
@@ -6014,14 +5918,14 @@
                 </a:solidFill>
                 <a:latin typeface="Calibri"/>
               </a:rPr>
-              <a:t> with an interactive app we built, changing which IMPROVE filters are in the calibration set and how it is built.</a:t>
+              <a:t>, the biggest gain so far.</a:t>
             </a:r>
           </a:p>
         </p:txBody>
       </p:sp>
       <p:pic>
         <p:nvPicPr>
-          <p:cNvPr id="55" name="Picture 54" descr="fp_explorer.png"/>
+          <p:cNvPr id="53" name="Picture 52" descr="fp_baseline.png"/>
           <p:cNvPicPr>
             <a:picLocks noChangeAspect="1"/>
           </p:cNvPicPr>
@@ -6035,8 +5939,8 @@
         </p:blipFill>
         <p:spPr>
           <a:xfrm>
-            <a:off x="27203400" y="16353163"/>
-            <a:ext cx="11978640" cy="4686698"/>
+            <a:off x="27203400" y="8101330"/>
+            <a:ext cx="11978640" cy="6035683"/>
           </a:xfrm>
           <a:prstGeom prst="rect">
             <a:avLst/>
@@ -6045,14 +5949,14 @@
       </p:pic>
       <p:sp>
         <p:nvSpPr>
-          <p:cNvPr id="56" name="TextBox 55"/>
+          <p:cNvPr id="54" name="TextBox 53"/>
           <p:cNvSpPr txBox="1"/>
           <p:nvPr/>
         </p:nvSpPr>
         <p:spPr>
           <a:xfrm>
-            <a:off x="27203400" y="21085582"/>
-            <a:ext cx="11978640" cy="1597659"/>
+            <a:off x="27203400" y="14182733"/>
+            <a:ext cx="11978640" cy="896620"/>
           </a:xfrm>
           <a:prstGeom prst="rect">
             <a:avLst/>
@@ -6077,7 +5981,7 @@
                 </a:solidFill>
                 <a:latin typeface="Calibri"/>
               </a:rPr>
-              <a:t>Figure 8.</a:t>
+              <a:t>Figure 7.</a:t>
             </a:r>
             <a:r>
               <a:rPr sz="2300" b="0" i="0">
@@ -6086,20 +5990,20 @@
                 </a:solidFill>
                 <a:latin typeface="Calibri"/>
               </a:rPr>
-              <a:t> Each column is one calibration (3,138, all on baseline-corrected spectra), sorted by its Addis intercept (top). Tick marks show which choices it used. 254 put the intercept within ±0.5 µg/m³ of zero; 20 of those also have a slope between 0.8 and 1.25. Next: find out why those work, or whether it is chance.</a:t>
-            </a:r>
-          </a:p>
-        </p:txBody>
-      </p:sp>
-      <p:sp>
-        <p:nvSpPr>
-          <p:cNvPr id="57" name="TextBox 56"/>
+              <a:t> Same Addis filters, same axes as Figure 4. Correcting the baseline moves the intercept from -6.1 to -1.2 µg/m³, but the slope drops to 0.59.</a:t>
+            </a:r>
+          </a:p>
+        </p:txBody>
+      </p:sp>
+      <p:sp>
+        <p:nvSpPr>
+          <p:cNvPr id="55" name="TextBox 54"/>
           <p:cNvSpPr txBox="1"/>
           <p:nvPr/>
         </p:nvSpPr>
         <p:spPr>
           <a:xfrm>
-            <a:off x="27203400" y="22866122"/>
+            <a:off x="27203400" y="15262233"/>
             <a:ext cx="11978640" cy="1045209"/>
           </a:xfrm>
           <a:prstGeom prst="rect">
@@ -6125,7 +6029,7 @@
                 </a:solidFill>
                 <a:latin typeface="Calibri"/>
               </a:rPr>
-              <a:t>Step 3. One calibration per season</a:t>
+              <a:t>Step 2. Test thousands of calibrations</a:t>
             </a:r>
             <a:r>
               <a:rPr sz="2600" b="0" i="0">
@@ -6134,14 +6038,14 @@
                 </a:solidFill>
                 <a:latin typeface="Calibri"/>
               </a:rPr>
-              <a:t>, built from the IMPROVE filters whose spectra most resemble that season's Addis spectra.</a:t>
+              <a:t> with an interactive app we built, changing which IMPROVE filters are in the calibration set and how it is built.</a:t>
             </a:r>
           </a:p>
         </p:txBody>
       </p:sp>
       <p:pic>
         <p:nvPicPr>
-          <p:cNvPr id="58" name="Picture 57" descr="fp_seasons.png"/>
+          <p:cNvPr id="56" name="Picture 55" descr="fp_explorer.png"/>
           <p:cNvPicPr>
             <a:picLocks noChangeAspect="1"/>
           </p:cNvPicPr>
@@ -6155,8 +6059,8 @@
         </p:blipFill>
         <p:spPr>
           <a:xfrm>
-            <a:off x="27203400" y="23957052"/>
-            <a:ext cx="11978640" cy="4668286"/>
+            <a:off x="27203400" y="16353163"/>
+            <a:ext cx="11978640" cy="4686698"/>
           </a:xfrm>
           <a:prstGeom prst="rect">
             <a:avLst/>
@@ -6165,14 +6069,14 @@
       </p:pic>
       <p:sp>
         <p:nvSpPr>
-          <p:cNvPr id="59" name="TextBox 58"/>
+          <p:cNvPr id="57" name="TextBox 56"/>
           <p:cNvSpPr txBox="1"/>
           <p:nvPr/>
         </p:nvSpPr>
         <p:spPr>
           <a:xfrm>
-            <a:off x="27203400" y="28671058"/>
-            <a:ext cx="11978640" cy="896620"/>
+            <a:off x="27203400" y="21085582"/>
+            <a:ext cx="11978640" cy="1597659"/>
           </a:xfrm>
           <a:prstGeom prst="rect">
             <a:avLst/>
@@ -6197,6 +6101,126 @@
                 </a:solidFill>
                 <a:latin typeface="Calibri"/>
               </a:rPr>
+              <a:t>Figure 8.</a:t>
+            </a:r>
+            <a:r>
+              <a:rPr sz="2300" b="0" i="0">
+                <a:solidFill>
+                  <a:srgbClr val="55585E"/>
+                </a:solidFill>
+                <a:latin typeface="Calibri"/>
+              </a:rPr>
+              <a:t> Each column is one calibration (3,138, all on baseline-corrected spectra), sorted by its Addis intercept (top). Tick marks show which choices it used. 254 put the intercept within ±0.5 µg/m³ of zero; 20 of those also have a slope between 0.8 and 1.25. Next: find out why those work, or whether it is chance.</a:t>
+            </a:r>
+          </a:p>
+        </p:txBody>
+      </p:sp>
+      <p:sp>
+        <p:nvSpPr>
+          <p:cNvPr id="58" name="TextBox 57"/>
+          <p:cNvSpPr txBox="1"/>
+          <p:nvPr/>
+        </p:nvSpPr>
+        <p:spPr>
+          <a:xfrm>
+            <a:off x="27203400" y="22866122"/>
+            <a:ext cx="11978640" cy="1045209"/>
+          </a:xfrm>
+          <a:prstGeom prst="rect">
+            <a:avLst/>
+          </a:prstGeom>
+          <a:noFill/>
+        </p:spPr>
+        <p:txBody>
+          <a:bodyPr wrap="square" tIns="27432" bIns="27432">
+            <a:spAutoFit/>
+          </a:bodyPr>
+          <a:lstStyle/>
+          <a:p>
+            <a:pPr algn="l">
+              <a:spcAft>
+                <a:spcPts val="910"/>
+              </a:spcAft>
+            </a:pPr>
+            <a:r>
+              <a:rPr sz="2600" b="1" i="0">
+                <a:solidFill>
+                  <a:srgbClr val="22252A"/>
+                </a:solidFill>
+                <a:latin typeface="Calibri"/>
+              </a:rPr>
+              <a:t>Step 3. One calibration per season</a:t>
+            </a:r>
+            <a:r>
+              <a:rPr sz="2600" b="0" i="0">
+                <a:solidFill>
+                  <a:srgbClr val="22252A"/>
+                </a:solidFill>
+                <a:latin typeface="Calibri"/>
+              </a:rPr>
+              <a:t>, built from the IMPROVE filters whose spectra most resemble that season's Addis spectra.</a:t>
+            </a:r>
+          </a:p>
+        </p:txBody>
+      </p:sp>
+      <p:pic>
+        <p:nvPicPr>
+          <p:cNvPr id="59" name="Picture 58" descr="fp_seasons.png"/>
+          <p:cNvPicPr>
+            <a:picLocks noChangeAspect="1"/>
+          </p:cNvPicPr>
+          <p:nvPr/>
+        </p:nvPicPr>
+        <p:blipFill>
+          <a:blip r:embed="rId15"/>
+          <a:stretch>
+            <a:fillRect/>
+          </a:stretch>
+        </p:blipFill>
+        <p:spPr>
+          <a:xfrm>
+            <a:off x="27203400" y="23957052"/>
+            <a:ext cx="11978640" cy="4668286"/>
+          </a:xfrm>
+          <a:prstGeom prst="rect">
+            <a:avLst/>
+          </a:prstGeom>
+        </p:spPr>
+      </p:pic>
+      <p:sp>
+        <p:nvSpPr>
+          <p:cNvPr id="60" name="TextBox 59"/>
+          <p:cNvSpPr txBox="1"/>
+          <p:nvPr/>
+        </p:nvSpPr>
+        <p:spPr>
+          <a:xfrm>
+            <a:off x="27203400" y="28671058"/>
+            <a:ext cx="11978640" cy="896620"/>
+          </a:xfrm>
+          <a:prstGeom prst="rect">
+            <a:avLst/>
+          </a:prstGeom>
+          <a:noFill/>
+        </p:spPr>
+        <p:txBody>
+          <a:bodyPr wrap="square" tIns="27432" bIns="27432">
+            <a:spAutoFit/>
+          </a:bodyPr>
+          <a:lstStyle/>
+          <a:p>
+            <a:pPr algn="l">
+              <a:spcAft>
+                <a:spcPts val="460"/>
+              </a:spcAft>
+            </a:pPr>
+            <a:r>
+              <a:rPr sz="2300" b="1" i="0">
+                <a:solidFill>
+                  <a:srgbClr val="55585E"/>
+                </a:solidFill>
+                <a:latin typeface="Calibri"/>
+              </a:rPr>
               <a:t>Figure 9.</a:t>
             </a:r>
             <a:r>
@@ -6213,7 +6237,7 @@
       </p:sp>
       <p:sp>
         <p:nvSpPr>
-          <p:cNvPr id="60" name="Rectangle 59"/>
+          <p:cNvPr id="61" name="Rectangle 60"/>
           <p:cNvSpPr/>
           <p:nvPr/>
         </p:nvSpPr>
@@ -6266,7 +6290,7 @@
       </p:sp>
       <p:sp>
         <p:nvSpPr>
-          <p:cNvPr id="61" name="TextBox 60"/>
+          <p:cNvPr id="62" name="TextBox 61"/>
           <p:cNvSpPr txBox="1"/>
           <p:nvPr/>
         </p:nvSpPr>
@@ -6340,7 +6364,7 @@
       </p:sp>
       <p:sp>
         <p:nvSpPr>
-          <p:cNvPr id="62" name="Rectangle 61"/>
+          <p:cNvPr id="63" name="Rectangle 62"/>
           <p:cNvSpPr/>
           <p:nvPr/>
         </p:nvSpPr>
@@ -6393,7 +6417,7 @@
       </p:sp>
       <p:sp>
         <p:nvSpPr>
-          <p:cNvPr id="63" name="TextBox 62"/>
+          <p:cNvPr id="64" name="TextBox 63"/>
           <p:cNvSpPr txBox="1"/>
           <p:nvPr/>
         </p:nvSpPr>

</xml_diff>